<commit_message>
Clean up temp generators and refresh slide deck
- Drop one-off scripts (make_slides.py, make_pdf.py) now that the
  deck is built and verified.
- Drop SLIDES.md and TEAM_ROLES.md drafts (content moved into the
  pptx and into docs/).
- Refresh MedFAQ_Slides.pptx from the latest content.

Co-Authored-By: Claude Opus 4.7 (1M context) <noreply@anthropic.com>
</commit_message>
<xml_diff>
--- a/MedFAQ_Slides.pptx
+++ b/MedFAQ_Slides.pptx
@@ -312,7 +312,7 @@
           <a:p>
             <a:fld id="{5BCAD085-E8A6-8845-BD4E-CB4CCA059FC4}" type="datetimeFigureOut">
               <a:rPr lang="en-US" smtClean="0"/>
-              <a:t>6/3/2026</a:t>
+              <a:t>6/10/2026</a:t>
             </a:fld>
             <a:endParaRPr lang="en-US"/>
           </a:p>
@@ -480,7 +480,7 @@
           <a:p>
             <a:fld id="{5BCAD085-E8A6-8845-BD4E-CB4CCA059FC4}" type="datetimeFigureOut">
               <a:rPr lang="en-US" smtClean="0"/>
-              <a:t>6/3/2026</a:t>
+              <a:t>6/10/2026</a:t>
             </a:fld>
             <a:endParaRPr lang="en-US"/>
           </a:p>
@@ -658,7 +658,7 @@
           <a:p>
             <a:fld id="{5BCAD085-E8A6-8845-BD4E-CB4CCA059FC4}" type="datetimeFigureOut">
               <a:rPr lang="en-US" smtClean="0"/>
-              <a:t>6/3/2026</a:t>
+              <a:t>6/10/2026</a:t>
             </a:fld>
             <a:endParaRPr lang="en-US"/>
           </a:p>
@@ -826,7 +826,7 @@
           <a:p>
             <a:fld id="{5BCAD085-E8A6-8845-BD4E-CB4CCA059FC4}" type="datetimeFigureOut">
               <a:rPr lang="en-US" smtClean="0"/>
-              <a:t>6/3/2026</a:t>
+              <a:t>6/10/2026</a:t>
             </a:fld>
             <a:endParaRPr lang="en-US"/>
           </a:p>
@@ -1071,7 +1071,7 @@
           <a:p>
             <a:fld id="{5BCAD085-E8A6-8845-BD4E-CB4CCA059FC4}" type="datetimeFigureOut">
               <a:rPr lang="en-US" smtClean="0"/>
-              <a:t>6/3/2026</a:t>
+              <a:t>6/10/2026</a:t>
             </a:fld>
             <a:endParaRPr lang="en-US"/>
           </a:p>
@@ -1356,7 +1356,7 @@
           <a:p>
             <a:fld id="{5BCAD085-E8A6-8845-BD4E-CB4CCA059FC4}" type="datetimeFigureOut">
               <a:rPr lang="en-US" smtClean="0"/>
-              <a:t>6/3/2026</a:t>
+              <a:t>6/10/2026</a:t>
             </a:fld>
             <a:endParaRPr lang="en-US"/>
           </a:p>
@@ -1775,7 +1775,7 @@
           <a:p>
             <a:fld id="{5BCAD085-E8A6-8845-BD4E-CB4CCA059FC4}" type="datetimeFigureOut">
               <a:rPr lang="en-US" smtClean="0"/>
-              <a:t>6/3/2026</a:t>
+              <a:t>6/10/2026</a:t>
             </a:fld>
             <a:endParaRPr lang="en-US"/>
           </a:p>
@@ -1892,7 +1892,7 @@
           <a:p>
             <a:fld id="{5BCAD085-E8A6-8845-BD4E-CB4CCA059FC4}" type="datetimeFigureOut">
               <a:rPr lang="en-US" smtClean="0"/>
-              <a:t>6/3/2026</a:t>
+              <a:t>6/10/2026</a:t>
             </a:fld>
             <a:endParaRPr lang="en-US"/>
           </a:p>
@@ -1987,7 +1987,7 @@
           <a:p>
             <a:fld id="{5BCAD085-E8A6-8845-BD4E-CB4CCA059FC4}" type="datetimeFigureOut">
               <a:rPr lang="en-US" smtClean="0"/>
-              <a:t>6/3/2026</a:t>
+              <a:t>6/10/2026</a:t>
             </a:fld>
             <a:endParaRPr lang="en-US"/>
           </a:p>
@@ -2262,7 +2262,7 @@
           <a:p>
             <a:fld id="{5BCAD085-E8A6-8845-BD4E-CB4CCA059FC4}" type="datetimeFigureOut">
               <a:rPr lang="en-US" smtClean="0"/>
-              <a:t>6/3/2026</a:t>
+              <a:t>6/10/2026</a:t>
             </a:fld>
             <a:endParaRPr lang="en-US"/>
           </a:p>
@@ -2514,7 +2514,7 @@
           <a:p>
             <a:fld id="{5BCAD085-E8A6-8845-BD4E-CB4CCA059FC4}" type="datetimeFigureOut">
               <a:rPr lang="en-US" smtClean="0"/>
-              <a:t>6/3/2026</a:t>
+              <a:t>6/10/2026</a:t>
             </a:fld>
             <a:endParaRPr lang="en-US"/>
           </a:p>
@@ -2725,7 +2725,7 @@
           <a:p>
             <a:fld id="{5BCAD085-E8A6-8845-BD4E-CB4CCA059FC4}" type="datetimeFigureOut">
               <a:rPr lang="en-US" smtClean="0"/>
-              <a:t>6/3/2026</a:t>
+              <a:t>6/10/2026</a:t>
             </a:fld>
             <a:endParaRPr lang="en-US"/>
           </a:p>
@@ -3277,29 +3277,18 @@
               <a:t>Abdul Ghani · Anas Bhatti · Muhammad Salman </a:t>
             </a:r>
             <a:r>
-              <a:rPr lang="en-US" sz="1400">
+              <a:rPr lang="en-US" sz="1400" dirty="0">
                 <a:solidFill>
                   <a:srgbClr val="1C1717"/>
                 </a:solidFill>
               </a:rPr>
-              <a:t>· Raja Mahad </a:t>
-            </a:r>
-            <a:r>
-              <a:rPr lang="en-US" sz="1400" dirty="0">
-                <a:solidFill>
-                  <a:srgbClr val="1C1717"/>
-                </a:solidFill>
-              </a:rPr>
-              <a:t>Ali</a:t>
-            </a:r>
-            <a:r>
-              <a:rPr sz="1400" b="0" dirty="0">
-                <a:solidFill>
-                  <a:srgbClr val="1C1717"/>
-                </a:solidFill>
-              </a:rPr>
-              <a:t>· 5th member</a:t>
-            </a:r>
+              <a:t>· Raja Mahad Ali</a:t>
+            </a:r>
+            <a:endParaRPr sz="1400" b="0" dirty="0">
+              <a:solidFill>
+                <a:srgbClr val="1C1717"/>
+              </a:solidFill>
+            </a:endParaRPr>
           </a:p>
         </p:txBody>
       </p:sp>
@@ -3415,7 +3404,7 @@
         <p:spPr>
           <a:xfrm>
             <a:off x="457200" y="365760"/>
-            <a:ext cx="10972800" cy="640080"/>
+            <a:ext cx="10972800" cy="492443"/>
           </a:xfrm>
           <a:prstGeom prst="rect">
             <a:avLst/>
@@ -3430,12 +3419,20 @@
           <a:p>
             <a:pPr algn="l"/>
             <a:r>
-              <a:rPr sz="3200" b="1">
+              <a:rPr lang="en-US" sz="3200" b="1" dirty="0">
                 <a:solidFill>
                   <a:srgbClr val="1C1717"/>
                 </a:solidFill>
               </a:rPr>
-              <a:t>Team — 4 NLP-heavy roles</a:t>
+              <a:t>NLP</a:t>
+            </a:r>
+            <a:r>
+              <a:rPr sz="3200" b="1" dirty="0">
+                <a:solidFill>
+                  <a:srgbClr val="1C1717"/>
+                </a:solidFill>
+              </a:rPr>
+              <a:t> roles</a:t>
             </a:r>
           </a:p>
         </p:txBody>
@@ -3483,7 +3480,7 @@
         <p:spPr>
           <a:xfrm>
             <a:off x="548640" y="1783080"/>
-            <a:ext cx="11338560" cy="4754880"/>
+            <a:ext cx="11338560" cy="3785652"/>
           </a:xfrm>
           <a:prstGeom prst="rect">
             <a:avLst/>
@@ -3498,77 +3495,237 @@
           <a:p>
             <a:pPr algn="l"/>
             <a:r>
-              <a:rPr sz="1200" b="1">
+              <a:rPr sz="2000" b="1" dirty="0">
                 <a:solidFill>
                   <a:srgbClr val="1C1717"/>
                 </a:solidFill>
               </a:rPr>
-              <a:t>•  Member 1 — Abdul Ghani (F23607005). Token + Retrieval NLP</a:t>
-            </a:r>
-            <a:r>
-              <a:rPr sz="1100">
-                <a:solidFill>
-                  <a:srgbClr val="78716C"/>
-                </a:solidFill>
-              </a:rPr>
-              <a:t>  — tokeniser, Porter stemmer, lemmatiser, lexicon + HMM POS, spell correct, Roman-Urdu, TF-IDF (word + char), BM25, LSA, PPMI, Word2Vec, BPE, Kneser-Ney LM, WMD, PRF, 5-channel blender + chat UI + /playground</a:t>
+              <a:t>•  Member 1</a:t>
+            </a:r>
+            <a:r>
+              <a:rPr lang="en-US" sz="2000" b="1" dirty="0">
+                <a:solidFill>
+                  <a:srgbClr val="1C1717"/>
+                </a:solidFill>
+              </a:rPr>
+              <a:t>,</a:t>
+            </a:r>
+            <a:r>
+              <a:rPr sz="2000" b="1" dirty="0">
+                <a:solidFill>
+                  <a:srgbClr val="1C1717"/>
+                </a:solidFill>
+              </a:rPr>
+              <a:t> Abdul Ghani (F23607005). Token + Retrieval NLP</a:t>
+            </a:r>
+            <a:r>
+              <a:rPr sz="2000" dirty="0">
+                <a:solidFill>
+                  <a:srgbClr val="78716C"/>
+                </a:solidFill>
+              </a:rPr>
+              <a:t>   </a:t>
+            </a:r>
+            <a:r>
+              <a:rPr sz="2000" dirty="0" err="1">
+                <a:solidFill>
+                  <a:srgbClr val="78716C"/>
+                </a:solidFill>
+              </a:rPr>
+              <a:t>tokeniser</a:t>
+            </a:r>
+            <a:r>
+              <a:rPr sz="2000" dirty="0">
+                <a:solidFill>
+                  <a:srgbClr val="78716C"/>
+                </a:solidFill>
+              </a:rPr>
+              <a:t>, Porter stemmer, </a:t>
+            </a:r>
+            <a:r>
+              <a:rPr sz="2000" dirty="0" err="1">
+                <a:solidFill>
+                  <a:srgbClr val="78716C"/>
+                </a:solidFill>
+              </a:rPr>
+              <a:t>lemmatiser</a:t>
+            </a:r>
+            <a:r>
+              <a:rPr sz="2000" dirty="0">
+                <a:solidFill>
+                  <a:srgbClr val="78716C"/>
+                </a:solidFill>
+              </a:rPr>
+              <a:t>, lexicon + HMM POS, spell correct, Roman-Urdu, TF-IDF (word + char), BM25, LSA, PPMI, Word2Vec, BPE, Kneser-Ney LM, WMD, PRF, 5-channel blender + chat UI + /playground</a:t>
             </a:r>
           </a:p>
           <a:p>
             <a:pPr algn="l"/>
             <a:r>
-              <a:rPr sz="1200" b="1">
+              <a:rPr sz="2000" b="1" dirty="0">
                 <a:solidFill>
                   <a:srgbClr val="1C1717"/>
                 </a:solidFill>
               </a:rPr>
-              <a:t>•  Member 2 — Anas Bhatti (F23607044). Extraction + Classification NLP</a:t>
-            </a:r>
-            <a:r>
-              <a:rPr sz="1100">
-                <a:solidFill>
-                  <a:srgbClr val="78716C"/>
-                </a:solidFill>
-              </a:rPr>
-              <a:t>  — Medical NER (dict + perceptron + linear-chain CRF), negation, sentiment, triage, question type, slot extractor, TextRank keywords + summary, KG triples, Naive Bayes + MLP + Transformer intent classifier, /architecture</a:t>
+              <a:t>•  Member 2 </a:t>
+            </a:r>
+            <a:r>
+              <a:rPr lang="en-US" sz="2000" b="1" dirty="0">
+                <a:solidFill>
+                  <a:srgbClr val="1C1717"/>
+                </a:solidFill>
+              </a:rPr>
+              <a:t>, </a:t>
+            </a:r>
+            <a:r>
+              <a:rPr sz="2000" b="1" dirty="0">
+                <a:solidFill>
+                  <a:srgbClr val="1C1717"/>
+                </a:solidFill>
+              </a:rPr>
+              <a:t>Anas Bhatti (F23607044). Extraction + Classification NLP</a:t>
+            </a:r>
+            <a:r>
+              <a:rPr sz="2000" dirty="0">
+                <a:solidFill>
+                  <a:srgbClr val="78716C"/>
+                </a:solidFill>
+              </a:rPr>
+              <a:t>  Medical NER (</a:t>
+            </a:r>
+            <a:r>
+              <a:rPr sz="2000" dirty="0" err="1">
+                <a:solidFill>
+                  <a:srgbClr val="78716C"/>
+                </a:solidFill>
+              </a:rPr>
+              <a:t>dict</a:t>
+            </a:r>
+            <a:r>
+              <a:rPr sz="2000" dirty="0">
+                <a:solidFill>
+                  <a:srgbClr val="78716C"/>
+                </a:solidFill>
+              </a:rPr>
+              <a:t> + perceptron + linear-chain CRF), negation, sentiment, triage, question type, slot extractor, </a:t>
+            </a:r>
+            <a:r>
+              <a:rPr sz="2000" dirty="0" err="1">
+                <a:solidFill>
+                  <a:srgbClr val="78716C"/>
+                </a:solidFill>
+              </a:rPr>
+              <a:t>TextRank</a:t>
+            </a:r>
+            <a:r>
+              <a:rPr sz="2000" dirty="0">
+                <a:solidFill>
+                  <a:srgbClr val="78716C"/>
+                </a:solidFill>
+              </a:rPr>
+              <a:t> keywords + summary, KG triples, Naive Bayes + MLP , /architecture</a:t>
             </a:r>
           </a:p>
           <a:p>
             <a:pPr algn="l"/>
             <a:r>
-              <a:rPr sz="1200" b="1">
+              <a:rPr sz="2000" b="1" dirty="0">
                 <a:solidFill>
                   <a:srgbClr val="1C1717"/>
                 </a:solidFill>
               </a:rPr>
-              <a:t>•  Member 3 — Muhammad Salman (F23607037). Generation + Dialog NLP</a:t>
-            </a:r>
-            <a:r>
-              <a:rPr sz="1100">
-                <a:solidFill>
-                  <a:srgbClr val="78716C"/>
-                </a:solidFill>
-              </a:rPr>
-              <a:t>  — Seq2seq encoder-decoder with Bahdanau attention, grounded generator, MLP, dual encoder, K-Means, real-time auto-FAQ miner, dialog manager, MMR diversification, LTR reranker, coreference, live FAQ counters</a:t>
+              <a:t>•  Member 3</a:t>
+            </a:r>
+            <a:r>
+              <a:rPr lang="en-US" sz="2000" b="1" dirty="0">
+                <a:solidFill>
+                  <a:srgbClr val="1C1717"/>
+                </a:solidFill>
+              </a:rPr>
+              <a:t>, </a:t>
+            </a:r>
+            <a:r>
+              <a:rPr sz="2000" b="1" dirty="0">
+                <a:solidFill>
+                  <a:srgbClr val="1C1717"/>
+                </a:solidFill>
+              </a:rPr>
+              <a:t>Muhammad Salman (F23607037). Generation + Dialog NLP</a:t>
+            </a:r>
+            <a:r>
+              <a:rPr sz="2000" dirty="0">
+                <a:solidFill>
+                  <a:srgbClr val="78716C"/>
+                </a:solidFill>
+              </a:rPr>
+              <a:t>   Seq2seq encoder-decoder with </a:t>
+            </a:r>
+            <a:r>
+              <a:rPr sz="2000" dirty="0" err="1">
+                <a:solidFill>
+                  <a:srgbClr val="78716C"/>
+                </a:solidFill>
+              </a:rPr>
+              <a:t>Bahdanau</a:t>
+            </a:r>
+            <a:r>
+              <a:rPr sz="2000" dirty="0">
+                <a:solidFill>
+                  <a:srgbClr val="78716C"/>
+                </a:solidFill>
+              </a:rPr>
+              <a:t> attention, grounded generator, MLP, dual encoder, K-Means, real-time auto-FAQ miner, dialog manager, MMR diversification, LTR </a:t>
+            </a:r>
+            <a:r>
+              <a:rPr sz="2000" dirty="0" err="1">
+                <a:solidFill>
+                  <a:srgbClr val="78716C"/>
+                </a:solidFill>
+              </a:rPr>
+              <a:t>reranker</a:t>
+            </a:r>
+            <a:r>
+              <a:rPr sz="2000" dirty="0">
+                <a:solidFill>
+                  <a:srgbClr val="78716C"/>
+                </a:solidFill>
+              </a:rPr>
+              <a:t>, coreference, live FAQ counters</a:t>
             </a:r>
           </a:p>
           <a:p>
             <a:pPr algn="l"/>
             <a:r>
-              <a:rPr sz="1200" b="1">
+              <a:rPr sz="2000" b="1" dirty="0">
                 <a:solidFill>
                   <a:srgbClr val="1C1717"/>
                 </a:solidFill>
               </a:rPr>
-              <a:t>•  Member 4 — Data + Eval + Deploy</a:t>
-            </a:r>
-            <a:r>
-              <a:rPr sz="1100">
-                <a:solidFill>
-                  <a:srgbClr val="78716C"/>
-                </a:solidFill>
-              </a:rPr>
-              <a:t>  — 214 hand-written FAQs, 6-way intent augmentation (1517 examples), 14,357 synthetic chat sessions, PHI scrub, offline mining pipeline, eval harness (P@1, MRR, Recall@5), 62-test integration suite, Docker</a:t>
+              <a:t>•  Member 4</a:t>
+            </a:r>
+            <a:r>
+              <a:rPr lang="en-US" sz="2000" b="1" dirty="0">
+                <a:solidFill>
+                  <a:srgbClr val="1C1717"/>
+                </a:solidFill>
+              </a:rPr>
+              <a:t>, Mahad Ali</a:t>
+            </a:r>
+            <a:r>
+              <a:rPr sz="2000" b="1" dirty="0">
+                <a:solidFill>
+                  <a:srgbClr val="1C1717"/>
+                </a:solidFill>
+              </a:rPr>
+              <a:t> Data + Eval + Deploy</a:t>
+            </a:r>
+            <a:r>
+              <a:rPr sz="2000" dirty="0">
+                <a:solidFill>
+                  <a:srgbClr val="78716C"/>
+                </a:solidFill>
+              </a:rPr>
+              <a:t>   214 hand-written FAQs, 6-way intent augmentation (1517 examples), 14,357 synthetic chat sessions, PHI scrub, offline mining pipeline, eval harness (P@1, MRR, Recall@5), 62-test integration suite, Docker</a:t>
             </a:r>
           </a:p>
         </p:txBody>
@@ -3753,7 +3910,7 @@
         <p:spPr>
           <a:xfrm>
             <a:off x="548640" y="2468880"/>
-            <a:ext cx="11338560" cy="4114800"/>
+            <a:ext cx="11338560" cy="1384995"/>
           </a:xfrm>
           <a:prstGeom prst="rect">
             <a:avLst/>
@@ -3768,7 +3925,7 @@
           <a:p>
             <a:pPr algn="l"/>
             <a:r>
-              <a:rPr sz="1400" b="1">
+              <a:rPr sz="1400" b="1" dirty="0">
                 <a:solidFill>
                   <a:srgbClr val="1C1717"/>
                 </a:solidFill>
@@ -3776,7 +3933,7 @@
               <a:t>•  http://localhost:3000/</a:t>
             </a:r>
             <a:r>
-              <a:rPr sz="1300">
+              <a:rPr sz="1300" dirty="0">
                 <a:solidFill>
                   <a:srgbClr val="78716C"/>
                 </a:solidFill>
@@ -3787,7 +3944,7 @@
           <a:p>
             <a:pPr algn="l"/>
             <a:r>
-              <a:rPr sz="1400" b="1">
+              <a:rPr sz="1400" b="1" dirty="0">
                 <a:solidFill>
                   <a:srgbClr val="1C1717"/>
                 </a:solidFill>
@@ -3795,7 +3952,7 @@
               <a:t>•  /chat/radiology</a:t>
             </a:r>
             <a:r>
-              <a:rPr sz="1300">
+              <a:rPr sz="1300" dirty="0">
                 <a:solidFill>
                   <a:srgbClr val="78716C"/>
                 </a:solidFill>
@@ -3806,7 +3963,7 @@
           <a:p>
             <a:pPr algn="l"/>
             <a:r>
-              <a:rPr sz="1400" b="1">
+              <a:rPr sz="1400" b="1" dirty="0">
                 <a:solidFill>
                   <a:srgbClr val="1C1717"/>
                 </a:solidFill>
@@ -3814,7 +3971,7 @@
               <a:t>•  /playground</a:t>
             </a:r>
             <a:r>
-              <a:rPr sz="1300">
+              <a:rPr sz="1300" dirty="0">
                 <a:solidFill>
                   <a:srgbClr val="78716C"/>
                 </a:solidFill>
@@ -3825,7 +3982,7 @@
           <a:p>
             <a:pPr algn="l"/>
             <a:r>
-              <a:rPr sz="1400" b="1">
+              <a:rPr sz="1400" b="1" dirty="0">
                 <a:solidFill>
                   <a:srgbClr val="1C1717"/>
                 </a:solidFill>
@@ -3833,7 +3990,7 @@
               <a:t>•  /architecture</a:t>
             </a:r>
             <a:r>
-              <a:rPr sz="1300">
+              <a:rPr sz="1300" dirty="0">
                 <a:solidFill>
                   <a:srgbClr val="78716C"/>
                 </a:solidFill>
@@ -3844,7 +4001,7 @@
           <a:p>
             <a:pPr algn="l"/>
             <a:r>
-              <a:rPr sz="1400" b="1">
+              <a:rPr sz="1400" b="1" dirty="0">
                 <a:solidFill>
                   <a:srgbClr val="1C1717"/>
                 </a:solidFill>
@@ -3852,7 +4009,7 @@
               <a:t>•  /admin</a:t>
             </a:r>
             <a:r>
-              <a:rPr sz="1300">
+              <a:rPr sz="1300" dirty="0">
                 <a:solidFill>
                   <a:srgbClr val="78716C"/>
                 </a:solidFill>
@@ -3863,53 +4020,15 @@
           <a:p>
             <a:pPr algn="l"/>
             <a:r>
-              <a:rPr sz="1400" b="1">
+              <a:rPr sz="1400" b="1" dirty="0">
                 <a:solidFill>
                   <a:srgbClr val="1C1717"/>
                 </a:solidFill>
               </a:rPr>
-              <a:t>•  python api/train_transformer.py --verbose</a:t>
-            </a:r>
-            <a:r>
-              <a:rPr sz="1300">
-                <a:solidFill>
-                  <a:srgbClr val="78716C"/>
-                </a:solidFill>
-              </a:rPr>
-              <a:t>  — train the from-scratch transformer (GPU auto-detected)</a:t>
-            </a:r>
-          </a:p>
-          <a:p>
-            <a:pPr algn="l"/>
-            <a:r>
-              <a:rPr sz="1400" b="1">
-                <a:solidFill>
-                  <a:srgbClr val="1C1717"/>
-                </a:solidFill>
-              </a:rPr>
-              <a:t>•  python api/eval.py</a:t>
-            </a:r>
-            <a:r>
-              <a:rPr sz="1300">
-                <a:solidFill>
-                  <a:srgbClr val="78716C"/>
-                </a:solidFill>
-              </a:rPr>
-              <a:t>  — regenerate EVALUATION_REPORT.md from 116 held-out queries</a:t>
-            </a:r>
-          </a:p>
-          <a:p>
-            <a:pPr algn="l"/>
-            <a:r>
-              <a:rPr sz="1400" b="1">
-                <a:solidFill>
-                  <a:srgbClr val="1C1717"/>
-                </a:solidFill>
-              </a:rPr>
               <a:t>•  python api/final_test.py</a:t>
             </a:r>
             <a:r>
-              <a:rPr sz="1300">
+              <a:rPr sz="1300" dirty="0">
                 <a:solidFill>
                   <a:srgbClr val="78716C"/>
                 </a:solidFill>
@@ -4031,7 +4150,7 @@
         <p:spPr>
           <a:xfrm>
             <a:off x="457200" y="1143000"/>
-            <a:ext cx="10972800" cy="457200"/>
+            <a:ext cx="10972800" cy="215444"/>
           </a:xfrm>
           <a:prstGeom prst="rect">
             <a:avLst/>
@@ -4046,12 +4165,44 @@
           <a:p>
             <a:pPr algn="l"/>
             <a:r>
-              <a:rPr sz="1400" b="0">
-                <a:solidFill>
-                  <a:srgbClr val="78716C"/>
-                </a:solidFill>
-              </a:rPr>
-              <a:t>Problem · Patients ask the same questions every week.</a:t>
+              <a:rPr sz="1400" b="0" dirty="0">
+                <a:solidFill>
+                  <a:srgbClr val="78716C"/>
+                </a:solidFill>
+              </a:rPr>
+              <a:t>Problem · </a:t>
+            </a:r>
+            <a:r>
+              <a:rPr lang="en-US" sz="1400" b="0" dirty="0">
+                <a:solidFill>
+                  <a:srgbClr val="78716C"/>
+                </a:solidFill>
+              </a:rPr>
+              <a:t>Different </a:t>
+            </a:r>
+            <a:r>
+              <a:rPr sz="1400" b="0" dirty="0">
+                <a:solidFill>
+                  <a:srgbClr val="78716C"/>
+                </a:solidFill>
+              </a:rPr>
+              <a:t>Patients ask </a:t>
+            </a:r>
+            <a:r>
+              <a:rPr lang="en-US" sz="1400" b="0" dirty="0">
+                <a:solidFill>
+                  <a:srgbClr val="78716C"/>
+                </a:solidFill>
+              </a:rPr>
+              <a:t>almost </a:t>
+            </a:r>
+            <a:r>
+              <a:rPr sz="1400" b="0" dirty="0">
+                <a:solidFill>
+                  <a:srgbClr val="78716C"/>
+                </a:solidFill>
+              </a:rPr>
+              <a:t>same questions every week.</a:t>
             </a:r>
           </a:p>
         </p:txBody>
@@ -4065,7 +4216,7 @@
         <p:spPr>
           <a:xfrm>
             <a:off x="640080" y="1783080"/>
-            <a:ext cx="10972800" cy="4572000"/>
+            <a:ext cx="10972800" cy="1631216"/>
           </a:xfrm>
           <a:prstGeom prst="rect">
             <a:avLst/>
@@ -4080,7 +4231,7 @@
           <a:p>
             <a:pPr algn="l"/>
             <a:r>
-              <a:rPr sz="1500" b="1">
+              <a:rPr sz="2000" b="1" dirty="0">
                 <a:solidFill>
                   <a:srgbClr val="1C1717"/>
                 </a:solidFill>
@@ -4088,18 +4239,18 @@
               <a:t>•  Goal</a:t>
             </a:r>
             <a:r>
-              <a:rPr sz="1400">
-                <a:solidFill>
-                  <a:srgbClr val="78716C"/>
-                </a:solidFill>
-              </a:rPr>
-              <a:t>  — Retrieval chatbot that answers from an approved, clinician-reviewed FAQ index across three specialties.</a:t>
+              <a:rPr sz="2000" dirty="0">
+                <a:solidFill>
+                  <a:srgbClr val="78716C"/>
+                </a:solidFill>
+              </a:rPr>
+              <a:t>  Retrieval chatbot that answers from an approved, clinician-reviewed index across three specialties.</a:t>
             </a:r>
           </a:p>
           <a:p>
             <a:pPr algn="l"/>
             <a:r>
-              <a:rPr sz="1500" b="1">
+              <a:rPr sz="2000" b="1" dirty="0">
                 <a:solidFill>
                   <a:srgbClr val="1C1717"/>
                 </a:solidFill>
@@ -4107,107 +4258,58 @@
               <a:t>•  Specialties</a:t>
             </a:r>
             <a:r>
-              <a:rPr sz="1400">
-                <a:solidFill>
-                  <a:srgbClr val="78716C"/>
-                </a:solidFill>
-              </a:rPr>
-              <a:t>  — Radiology · Physiotherapy · Cardiovascular.</a:t>
+              <a:rPr sz="2000" dirty="0">
+                <a:solidFill>
+                  <a:srgbClr val="78716C"/>
+                </a:solidFill>
+              </a:rPr>
+              <a:t>   Radiology · Physiotherapy · Cardiovascular.</a:t>
             </a:r>
           </a:p>
           <a:p>
             <a:pPr algn="l"/>
             <a:r>
-              <a:rPr sz="1500" b="1">
+              <a:rPr sz="2000" b="1" dirty="0">
                 <a:solidFill>
                   <a:srgbClr val="1C1717"/>
                 </a:solidFill>
               </a:rPr>
-              <a:t>•  Honesty</a:t>
-            </a:r>
-            <a:r>
-              <a:rPr sz="1400">
-                <a:solidFill>
-                  <a:srgbClr val="78716C"/>
-                </a:solidFill>
-              </a:rPr>
-              <a:t>  — Every reply is a real, human-written FAQ entry. No hallucination.</a:t>
+              <a:t>•  Hard constraint</a:t>
+            </a:r>
+            <a:r>
+              <a:rPr sz="2000" dirty="0">
+                <a:solidFill>
+                  <a:srgbClr val="78716C"/>
+                </a:solidFill>
+              </a:rPr>
+              <a:t>  No </a:t>
+            </a:r>
+            <a:r>
+              <a:rPr lang="en-US" sz="2000" dirty="0">
+                <a:solidFill>
+                  <a:srgbClr val="78716C"/>
+                </a:solidFill>
+              </a:rPr>
+              <a:t>external or local LLM. </a:t>
             </a:r>
           </a:p>
           <a:p>
             <a:pPr algn="l"/>
             <a:r>
-              <a:rPr sz="1500" b="1">
+              <a:rPr sz="2000" b="1" dirty="0">
                 <a:solidFill>
                   <a:srgbClr val="1C1717"/>
                 </a:solidFill>
               </a:rPr>
-              <a:t>•  Hard constraint</a:t>
-            </a:r>
-            <a:r>
-              <a:rPr sz="1400">
-                <a:solidFill>
-                  <a:srgbClr val="78716C"/>
-                </a:solidFill>
-              </a:rPr>
-              <a:t>  — No LLM. No pretrained transformer. No sentence-transformers downloaded.</a:t>
-            </a:r>
-          </a:p>
-          <a:p>
-            <a:pPr algn="l"/>
-            <a:r>
-              <a:rPr sz="1500" b="1">
-                <a:solidFill>
-                  <a:srgbClr val="1C1717"/>
-                </a:solidFill>
-              </a:rPr>
-              <a:t>•  Hard constraint</a:t>
-            </a:r>
-            <a:r>
-              <a:rPr sz="1400">
-                <a:solidFill>
-                  <a:srgbClr val="78716C"/>
-                </a:solidFill>
-              </a:rPr>
-              <a:t>  — Every ML algorithm written by us (numpy or PyTorch tensors). ~3000 LoC.</a:t>
-            </a:r>
-          </a:p>
-          <a:p>
-            <a:pPr algn="l"/>
-            <a:r>
-              <a:rPr sz="1500" b="1">
-                <a:solidFill>
-                  <a:srgbClr val="1C1717"/>
-                </a:solidFill>
-              </a:rPr>
-              <a:t>•  Deploy</a:t>
-            </a:r>
-            <a:r>
-              <a:rPr sz="1400">
-                <a:solidFill>
-                  <a:srgbClr val="78716C"/>
-                </a:solidFill>
-              </a:rPr>
-              <a:t>  — Single `docker compose up` brings web + api + mongo live.</a:t>
-            </a:r>
-          </a:p>
-          <a:p>
-            <a:pPr algn="l"/>
-            <a:r>
-              <a:rPr sz="1500" b="1">
-                <a:solidFill>
-                  <a:srgbClr val="1C1717"/>
-                </a:solidFill>
-              </a:rPr>
               <a:t>•  Pakistan context</a:t>
             </a:r>
             <a:r>
-              <a:rPr sz="1400">
-                <a:solidFill>
-                  <a:srgbClr val="78716C"/>
-                </a:solidFill>
-              </a:rPr>
-              <a:t>  — Roman-Urdu phonetic input · 1122 emergency banner · PHI scrub.</a:t>
+              <a:rPr sz="2000" dirty="0">
+                <a:solidFill>
+                  <a:srgbClr val="78716C"/>
+                </a:solidFill>
+              </a:rPr>
+              <a:t>  Roman-Urdu phonetic input · PHI scrub.</a:t>
             </a:r>
           </a:p>
         </p:txBody>
@@ -4324,7 +4426,7 @@
         <p:spPr>
           <a:xfrm>
             <a:off x="457200" y="1143000"/>
-            <a:ext cx="10972800" cy="457200"/>
+            <a:ext cx="10972800" cy="215444"/>
           </a:xfrm>
           <a:prstGeom prst="rect">
             <a:avLst/>
@@ -4339,13 +4441,26 @@
           <a:p>
             <a:pPr algn="l"/>
             <a:r>
-              <a:rPr sz="1400" b="0">
-                <a:solidFill>
-                  <a:srgbClr val="78716C"/>
-                </a:solidFill>
-              </a:rPr>
-              <a:t>Each user turn flows top-to-bottom in ~22 ms p50.</a:t>
-            </a:r>
+              <a:rPr sz="1400" b="0" dirty="0">
+                <a:solidFill>
+                  <a:srgbClr val="78716C"/>
+                </a:solidFill>
+              </a:rPr>
+              <a:t>Each user turn flows top-to-bottom in ~22 </a:t>
+            </a:r>
+            <a:r>
+              <a:rPr sz="1400" b="0" dirty="0" err="1">
+                <a:solidFill>
+                  <a:srgbClr val="78716C"/>
+                </a:solidFill>
+              </a:rPr>
+              <a:t>ms.</a:t>
+            </a:r>
+            <a:endParaRPr sz="1400" b="0" dirty="0">
+              <a:solidFill>
+                <a:srgbClr val="78716C"/>
+              </a:solidFill>
+            </a:endParaRPr>
           </a:p>
         </p:txBody>
       </p:sp>
@@ -4358,7 +4473,7 @@
         <p:spPr>
           <a:xfrm>
             <a:off x="640080" y="1783080"/>
-            <a:ext cx="10972800" cy="4572000"/>
+            <a:ext cx="10972800" cy="2246769"/>
           </a:xfrm>
           <a:prstGeom prst="rect">
             <a:avLst/>
@@ -4373,7 +4488,7 @@
           <a:p>
             <a:pPr algn="l"/>
             <a:r>
-              <a:rPr sz="1400" b="1">
+              <a:rPr sz="2000" b="1" dirty="0">
                 <a:solidFill>
                   <a:srgbClr val="1C1717"/>
                 </a:solidFill>
@@ -4381,18 +4496,18 @@
               <a:t>•  Preprocess</a:t>
             </a:r>
             <a:r>
-              <a:rPr sz="1300">
-                <a:solidFill>
-                  <a:srgbClr val="78716C"/>
-                </a:solidFill>
-              </a:rPr>
-              <a:t>  — PHI scrub → Roman-Urdu expand → coreference → context augment → spell-correct.</a:t>
+              <a:rPr sz="2000" dirty="0">
+                <a:solidFill>
+                  <a:srgbClr val="78716C"/>
+                </a:solidFill>
+              </a:rPr>
+              <a:t>  PHI scrub → Roman-Urdu expand → coreference → context augment → spell-correct.</a:t>
             </a:r>
           </a:p>
           <a:p>
             <a:pPr algn="l"/>
             <a:r>
-              <a:rPr sz="1400" b="1">
+              <a:rPr sz="2000" b="1" dirty="0">
                 <a:solidFill>
                   <a:srgbClr val="1C1717"/>
                 </a:solidFill>
@@ -4400,18 +4515,50 @@
               <a:t>•  Understanding</a:t>
             </a:r>
             <a:r>
-              <a:rPr sz="1300">
-                <a:solidFill>
-                  <a:srgbClr val="78716C"/>
-                </a:solidFill>
-              </a:rPr>
-              <a:t>  — Tokeniser · POS (lexicon + HMM) · NER (dict + perceptron + CRF) · negation · sentiment · triage · intent (NB / MLP / Transformer).</a:t>
+              <a:rPr sz="2000" dirty="0">
+                <a:solidFill>
+                  <a:srgbClr val="78716C"/>
+                </a:solidFill>
+              </a:rPr>
+              <a:t> </a:t>
+            </a:r>
+            <a:r>
+              <a:rPr sz="2000" dirty="0" err="1">
+                <a:solidFill>
+                  <a:srgbClr val="78716C"/>
+                </a:solidFill>
+              </a:rPr>
+              <a:t>Tokeniser</a:t>
+            </a:r>
+            <a:r>
+              <a:rPr sz="2000" dirty="0">
+                <a:solidFill>
+                  <a:srgbClr val="78716C"/>
+                </a:solidFill>
+              </a:rPr>
+              <a:t> · POS (lexicon + HMM) · NER (</a:t>
+            </a:r>
+            <a:r>
+              <a:rPr sz="2000" dirty="0" err="1">
+                <a:solidFill>
+                  <a:srgbClr val="78716C"/>
+                </a:solidFill>
+              </a:rPr>
+              <a:t>dict</a:t>
+            </a:r>
+            <a:r>
+              <a:rPr sz="2000" dirty="0">
+                <a:solidFill>
+                  <a:srgbClr val="78716C"/>
+                </a:solidFill>
+              </a:rPr>
+              <a:t> + perceptron + CRF) · negation · sentiment · triage · intent (NB / MLP / Transformer).</a:t>
             </a:r>
           </a:p>
           <a:p>
             <a:pPr algn="l"/>
             <a:r>
-              <a:rPr sz="1400" b="1">
+              <a:rPr sz="2000" b="1" dirty="0">
                 <a:solidFill>
                   <a:srgbClr val="1C1717"/>
                 </a:solidFill>
@@ -4419,37 +4566,61 @@
               <a:t>•  Retrieve (5 channels)</a:t>
             </a:r>
             <a:r>
-              <a:rPr sz="1300">
-                <a:solidFill>
-                  <a:srgbClr val="78716C"/>
-                </a:solidFill>
-              </a:rPr>
-              <a:t>  — TF-IDF word 0.20 · TF-IDF char 0.45 · BM25 0.25 · LSA 0.05 · PPMI 0.05.</a:t>
+              <a:rPr sz="2000" dirty="0">
+                <a:solidFill>
+                  <a:srgbClr val="78716C"/>
+                </a:solidFill>
+              </a:rPr>
+              <a:t>  TF-IDF word 0.20 · TF-IDF char 0.45 · BM25 0.25 · LSA 0.05 · PPMI 0.05.</a:t>
             </a:r>
           </a:p>
           <a:p>
             <a:pPr algn="l"/>
             <a:r>
-              <a:rPr sz="1400" b="1">
+              <a:rPr sz="2000" b="1" dirty="0">
                 <a:solidFill>
                   <a:srgbClr val="1C1717"/>
                 </a:solidFill>
               </a:rPr>
-              <a:t>•  Rerank</a:t>
-            </a:r>
-            <a:r>
-              <a:rPr sz="1300">
-                <a:solidFill>
-                  <a:srgbClr val="78716C"/>
-                </a:solidFill>
-              </a:rPr>
-              <a:t>  — PRF (Rocchio) → LTR (LogReg, 14 features) → MMR diversify.</a:t>
+              <a:t>•  </a:t>
+            </a:r>
+            <a:r>
+              <a:rPr sz="2000" b="1" dirty="0" err="1">
+                <a:solidFill>
+                  <a:srgbClr val="1C1717"/>
+                </a:solidFill>
+              </a:rPr>
+              <a:t>Rerank</a:t>
+            </a:r>
+            <a:r>
+              <a:rPr sz="2000" dirty="0">
+                <a:solidFill>
+                  <a:srgbClr val="78716C"/>
+                </a:solidFill>
+              </a:rPr>
+              <a:t> PRF (Rocchio) → LTR (</a:t>
+            </a:r>
+            <a:r>
+              <a:rPr sz="2000" dirty="0" err="1">
+                <a:solidFill>
+                  <a:srgbClr val="78716C"/>
+                </a:solidFill>
+              </a:rPr>
+              <a:t>LogReg</a:t>
+            </a:r>
+            <a:r>
+              <a:rPr sz="2000" dirty="0">
+                <a:solidFill>
+                  <a:srgbClr val="78716C"/>
+                </a:solidFill>
+              </a:rPr>
+              <a:t>, 14 features) → MMR diversify.</a:t>
             </a:r>
           </a:p>
           <a:p>
             <a:pPr algn="l"/>
             <a:r>
-              <a:rPr sz="1400" b="1">
+              <a:rPr sz="2000" b="1" dirty="0">
                 <a:solidFill>
                   <a:srgbClr val="1C1717"/>
                 </a:solidFill>
@@ -4457,18 +4628,18 @@
               <a:t>•  Dialog</a:t>
             </a:r>
             <a:r>
-              <a:rPr sz="1300">
-                <a:solidFill>
-                  <a:srgbClr val="78716C"/>
-                </a:solidFill>
-              </a:rPr>
-              <a:t>  — Empathic opener · triage banner · clarification · disambiguation card · stem-overlap highlight.</a:t>
+              <a:rPr sz="2000" dirty="0">
+                <a:solidFill>
+                  <a:srgbClr val="78716C"/>
+                </a:solidFill>
+              </a:rPr>
+              <a:t>  Empathic opener · triage banner · clarification · disambiguation card · stem-overlap highlight.</a:t>
             </a:r>
           </a:p>
           <a:p>
             <a:pPr algn="l"/>
             <a:r>
-              <a:rPr sz="1400" b="1">
+              <a:rPr sz="2000" b="1" dirty="0">
                 <a:solidFill>
                   <a:srgbClr val="1C1717"/>
                 </a:solidFill>
@@ -4476,32 +4647,18 @@
               <a:t>•  Reply</a:t>
             </a:r>
             <a:r>
-              <a:rPr sz="1300">
-                <a:solidFill>
-                  <a:srgbClr val="78716C"/>
-                </a:solidFill>
-              </a:rPr>
-              <a:t>  — answer + matched FAQ + score breakdown + NLP analysis + dialog meta.</a:t>
-            </a:r>
-          </a:p>
-          <a:p>
-            <a:pPr algn="l"/>
-            <a:r>
-              <a:rPr sz="1400" b="1">
-                <a:solidFill>
-                  <a:srgbClr val="1C1717"/>
-                </a:solidFill>
-              </a:rPr>
-              <a:t>•  Offline pipeline</a:t>
-            </a:r>
-            <a:r>
-              <a:rPr sz="1300">
-                <a:solidFill>
-                  <a:srgbClr val="78716C"/>
-                </a:solidFill>
-              </a:rPr>
-              <a:t>  — Chat-log → segment → normalise → embed (TF-IDF) → cluster (K-Means) → select → polish → publish.</a:t>
-            </a:r>
+              <a:rPr sz="2000" dirty="0">
+                <a:solidFill>
+                  <a:srgbClr val="78716C"/>
+                </a:solidFill>
+              </a:rPr>
+              <a:t> answer + score breakdown </a:t>
+            </a:r>
+            <a:endParaRPr lang="en-US" sz="2000" dirty="0">
+              <a:solidFill>
+                <a:srgbClr val="78716C"/>
+              </a:solidFill>
+            </a:endParaRPr>
           </a:p>
         </p:txBody>
       </p:sp>
@@ -4648,7 +4805,13 @@
           <p:cNvGraphicFramePr>
             <a:graphicFrameLocks noGrp="1"/>
           </p:cNvGraphicFramePr>
-          <p:nvPr/>
+          <p:nvPr>
+            <p:extLst>
+              <p:ext uri="{D42A27DB-BD31-4B8C-83A1-F6EECF244321}">
+                <p14:modId xmlns:p14="http://schemas.microsoft.com/office/powerpoint/2010/main" val="4142279299"/>
+              </p:ext>
+            </p:extLst>
+          </p:nvPr>
         </p:nvGraphicFramePr>
         <p:xfrm>
           <a:off x="457200" y="1691640"/>
@@ -4690,7 +4853,7 @@
                     <a:lstStyle/>
                     <a:p>
                       <a:r>
-                        <a:rPr sz="1200" b="1">
+                        <a:rPr sz="1400" b="1">
                           <a:solidFill>
                             <a:srgbClr val="1C1717"/>
                           </a:solidFill>
@@ -4707,7 +4870,7 @@
                     <a:lstStyle/>
                     <a:p>
                       <a:r>
-                        <a:rPr sz="1200" b="1">
+                        <a:rPr sz="1400" b="1">
                           <a:solidFill>
                             <a:srgbClr val="1C1717"/>
                           </a:solidFill>
@@ -4724,7 +4887,7 @@
                     <a:lstStyle/>
                     <a:p>
                       <a:r>
-                        <a:rPr sz="1200" b="1">
+                        <a:rPr sz="1400" b="1">
                           <a:solidFill>
                             <a:srgbClr val="1C1717"/>
                           </a:solidFill>
@@ -4748,7 +4911,7 @@
                     <a:lstStyle/>
                     <a:p>
                       <a:r>
-                        <a:rPr sz="1200">
+                        <a:rPr sz="1400">
                           <a:solidFill>
                             <a:srgbClr val="1C1717"/>
                           </a:solidFill>
@@ -4765,7 +4928,7 @@
                     <a:lstStyle/>
                     <a:p>
                       <a:r>
-                        <a:rPr sz="1200">
+                        <a:rPr sz="1400">
                           <a:solidFill>
                             <a:srgbClr val="1C1717"/>
                           </a:solidFill>
@@ -4782,7 +4945,7 @@
                     <a:lstStyle/>
                     <a:p>
                       <a:r>
-                        <a:rPr sz="1200">
+                        <a:rPr sz="1400">
                           <a:solidFill>
                             <a:srgbClr val="1C1717"/>
                           </a:solidFill>
@@ -4806,7 +4969,7 @@
                     <a:lstStyle/>
                     <a:p>
                       <a:r>
-                        <a:rPr sz="1200">
+                        <a:rPr sz="1400">
                           <a:solidFill>
                             <a:srgbClr val="1C1717"/>
                           </a:solidFill>
@@ -4823,7 +4986,7 @@
                     <a:lstStyle/>
                     <a:p>
                       <a:r>
-                        <a:rPr sz="1200">
+                        <a:rPr sz="1400">
                           <a:solidFill>
                             <a:srgbClr val="1C1717"/>
                           </a:solidFill>
@@ -4840,7 +5003,7 @@
                     <a:lstStyle/>
                     <a:p>
                       <a:r>
-                        <a:rPr sz="1200">
+                        <a:rPr sz="1400" dirty="0">
                           <a:solidFill>
                             <a:srgbClr val="1C1717"/>
                           </a:solidFill>
@@ -4864,7 +5027,7 @@
                     <a:lstStyle/>
                     <a:p>
                       <a:r>
-                        <a:rPr sz="1200">
+                        <a:rPr sz="1400">
                           <a:solidFill>
                             <a:srgbClr val="1C1717"/>
                           </a:solidFill>
@@ -4881,7 +5044,7 @@
                     <a:lstStyle/>
                     <a:p>
                       <a:r>
-                        <a:rPr sz="1200">
+                        <a:rPr sz="1400">
                           <a:solidFill>
                             <a:srgbClr val="1C1717"/>
                           </a:solidFill>
@@ -4898,7 +5061,7 @@
                     <a:lstStyle/>
                     <a:p>
                       <a:r>
-                        <a:rPr sz="1200">
+                        <a:rPr sz="1400" dirty="0">
                           <a:solidFill>
                             <a:srgbClr val="1C1717"/>
                           </a:solidFill>
@@ -4922,7 +5085,7 @@
                     <a:lstStyle/>
                     <a:p>
                       <a:r>
-                        <a:rPr sz="1200">
+                        <a:rPr sz="1400">
                           <a:solidFill>
                             <a:srgbClr val="1C1717"/>
                           </a:solidFill>
@@ -4939,7 +5102,7 @@
                     <a:lstStyle/>
                     <a:p>
                       <a:r>
-                        <a:rPr sz="1200">
+                        <a:rPr sz="1400">
                           <a:solidFill>
                             <a:srgbClr val="1C1717"/>
                           </a:solidFill>
@@ -4956,7 +5119,7 @@
                     <a:lstStyle/>
                     <a:p>
                       <a:r>
-                        <a:rPr sz="1200">
+                        <a:rPr sz="1400" dirty="0">
                           <a:solidFill>
                             <a:srgbClr val="1C1717"/>
                           </a:solidFill>
@@ -4980,7 +5143,7 @@
                     <a:lstStyle/>
                     <a:p>
                       <a:r>
-                        <a:rPr sz="1200">
+                        <a:rPr sz="1400">
                           <a:solidFill>
                             <a:srgbClr val="1C1717"/>
                           </a:solidFill>
@@ -4997,7 +5160,7 @@
                     <a:lstStyle/>
                     <a:p>
                       <a:r>
-                        <a:rPr sz="1200">
+                        <a:rPr sz="1400">
                           <a:solidFill>
                             <a:srgbClr val="1C1717"/>
                           </a:solidFill>
@@ -5014,7 +5177,7 @@
                     <a:lstStyle/>
                     <a:p>
                       <a:r>
-                        <a:rPr sz="1200">
+                        <a:rPr sz="1400" dirty="0">
                           <a:solidFill>
                             <a:srgbClr val="1C1717"/>
                           </a:solidFill>
@@ -5038,7 +5201,7 @@
                     <a:lstStyle/>
                     <a:p>
                       <a:r>
-                        <a:rPr sz="1200">
+                        <a:rPr sz="1400">
                           <a:solidFill>
                             <a:srgbClr val="1C1717"/>
                           </a:solidFill>
@@ -5055,7 +5218,7 @@
                     <a:lstStyle/>
                     <a:p>
                       <a:r>
-                        <a:rPr sz="1200">
+                        <a:rPr sz="1400">
                           <a:solidFill>
                             <a:srgbClr val="1C1717"/>
                           </a:solidFill>
@@ -5072,7 +5235,7 @@
                     <a:lstStyle/>
                     <a:p>
                       <a:r>
-                        <a:rPr sz="1200">
+                        <a:rPr sz="1400" dirty="0">
                           <a:solidFill>
                             <a:srgbClr val="1C1717"/>
                           </a:solidFill>
@@ -5096,7 +5259,7 @@
                     <a:lstStyle/>
                     <a:p>
                       <a:r>
-                        <a:rPr sz="1200">
+                        <a:rPr sz="1400">
                           <a:solidFill>
                             <a:srgbClr val="1C1717"/>
                           </a:solidFill>
@@ -5113,7 +5276,7 @@
                     <a:lstStyle/>
                     <a:p>
                       <a:r>
-                        <a:rPr sz="1200">
+                        <a:rPr sz="1400">
                           <a:solidFill>
                             <a:srgbClr val="1C1717"/>
                           </a:solidFill>
@@ -5130,7 +5293,7 @@
                     <a:lstStyle/>
                     <a:p>
                       <a:r>
-                        <a:rPr sz="1200">
+                        <a:rPr sz="1400" dirty="0">
                           <a:solidFill>
                             <a:srgbClr val="1C1717"/>
                           </a:solidFill>
@@ -5154,7 +5317,7 @@
                     <a:lstStyle/>
                     <a:p>
                       <a:r>
-                        <a:rPr sz="1200">
+                        <a:rPr sz="1400">
                           <a:solidFill>
                             <a:srgbClr val="1C1717"/>
                           </a:solidFill>
@@ -5171,7 +5334,7 @@
                     <a:lstStyle/>
                     <a:p>
                       <a:r>
-                        <a:rPr sz="1200">
+                        <a:rPr sz="1400">
                           <a:solidFill>
                             <a:srgbClr val="1C1717"/>
                           </a:solidFill>
@@ -5188,7 +5351,7 @@
                     <a:lstStyle/>
                     <a:p>
                       <a:r>
-                        <a:rPr sz="1200">
+                        <a:rPr sz="1400" dirty="0">
                           <a:solidFill>
                             <a:srgbClr val="1C1717"/>
                           </a:solidFill>
@@ -5218,7 +5381,7 @@
         <p:spPr>
           <a:xfrm>
             <a:off x="457200" y="6309360"/>
-            <a:ext cx="10972800" cy="365760"/>
+            <a:ext cx="10972800" cy="184666"/>
           </a:xfrm>
           <a:prstGeom prst="rect">
             <a:avLst/>
@@ -5233,12 +5396,28 @@
           <a:p>
             <a:pPr algn="l"/>
             <a:r>
-              <a:rPr sz="1200" b="0">
-                <a:solidFill>
-                  <a:srgbClr val="78716C"/>
-                </a:solidFill>
-              </a:rPr>
-              <a:t>Counts persist live in MongoDB on every chat match → popular FAQs surface to the top.</a:t>
+              <a:rPr sz="1200" b="0" dirty="0">
+                <a:solidFill>
+                  <a:srgbClr val="78716C"/>
+                </a:solidFill>
+              </a:rPr>
+              <a:t>Counts persist live in MongoDB on every chat match </a:t>
+            </a:r>
+            <a:r>
+              <a:rPr lang="en-US" sz="1200" b="0" dirty="0">
+                <a:solidFill>
+                  <a:srgbClr val="78716C"/>
+                </a:solidFill>
+              </a:rPr>
+              <a:t>-&gt;</a:t>
+            </a:r>
+            <a:r>
+              <a:rPr sz="1200" b="0" dirty="0">
+                <a:solidFill>
+                  <a:srgbClr val="78716C"/>
+                </a:solidFill>
+              </a:rPr>
+              <a:t> popular FAQs surface to the top.</a:t>
             </a:r>
           </a:p>
         </p:txBody>
@@ -5321,7 +5500,7 @@
         <p:spPr>
           <a:xfrm>
             <a:off x="457200" y="365760"/>
-            <a:ext cx="10972800" cy="640080"/>
+            <a:ext cx="10972800" cy="461665"/>
           </a:xfrm>
           <a:prstGeom prst="rect">
             <a:avLst/>
@@ -5336,13 +5515,26 @@
           <a:p>
             <a:pPr algn="l"/>
             <a:r>
-              <a:rPr sz="3000" b="1">
+              <a:rPr sz="3000" b="1" dirty="0">
                 <a:solidFill>
                   <a:srgbClr val="1C1717"/>
                 </a:solidFill>
               </a:rPr>
-              <a:t>Models — every one trained from scratch</a:t>
-            </a:r>
+              <a:t>Model</a:t>
+            </a:r>
+            <a:r>
+              <a:rPr lang="en-US" sz="3000" b="1" dirty="0">
+                <a:solidFill>
+                  <a:srgbClr val="1C1717"/>
+                </a:solidFill>
+              </a:rPr>
+              <a:t>s</a:t>
+            </a:r>
+            <a:endParaRPr sz="3000" b="1" dirty="0">
+              <a:solidFill>
+                <a:srgbClr val="1C1717"/>
+              </a:solidFill>
+            </a:endParaRPr>
           </a:p>
         </p:txBody>
       </p:sp>
@@ -5355,7 +5547,7 @@
         <p:spPr>
           <a:xfrm>
             <a:off x="457200" y="1097280"/>
-            <a:ext cx="5394960" cy="365760"/>
+            <a:ext cx="5394960" cy="230832"/>
           </a:xfrm>
           <a:prstGeom prst="rect">
             <a:avLst/>
@@ -5370,12 +5562,44 @@
           <a:p>
             <a:pPr algn="l"/>
             <a:r>
-              <a:rPr sz="1500" b="1">
+              <a:rPr lang="en-US" sz="1500" b="1" dirty="0" err="1">
                 <a:solidFill>
                   <a:srgbClr val="1C1717"/>
                 </a:solidFill>
               </a:rPr>
-              <a:t>Classical numpy (myml/)</a:t>
+              <a:t>Numpy</a:t>
+            </a:r>
+            <a:r>
+              <a:rPr lang="en-US" sz="1500" b="1" dirty="0">
+                <a:solidFill>
+                  <a:srgbClr val="1C1717"/>
+                </a:solidFill>
+              </a:rPr>
+              <a:t> </a:t>
+            </a:r>
+            <a:r>
+              <a:rPr sz="1500" b="1" dirty="0">
+                <a:solidFill>
+                  <a:srgbClr val="1C1717"/>
+                </a:solidFill>
+              </a:rPr>
+              <a:t>(</a:t>
+            </a:r>
+            <a:r>
+              <a:rPr sz="1500" b="1" dirty="0" err="1">
+                <a:solidFill>
+                  <a:srgbClr val="1C1717"/>
+                </a:solidFill>
+              </a:rPr>
+              <a:t>myml</a:t>
+            </a:r>
+            <a:r>
+              <a:rPr sz="1500" b="1" dirty="0">
+                <a:solidFill>
+                  <a:srgbClr val="1C1717"/>
+                </a:solidFill>
+              </a:rPr>
+              <a:t>/)</a:t>
             </a:r>
           </a:p>
         </p:txBody>
@@ -5389,7 +5613,7 @@
         <p:spPr>
           <a:xfrm>
             <a:off x="502920" y="1463040"/>
-            <a:ext cx="5486400" cy="4572000"/>
+            <a:ext cx="5486400" cy="3785652"/>
           </a:xfrm>
           <a:prstGeom prst="rect">
             <a:avLst/>
@@ -5404,7 +5628,7 @@
           <a:p>
             <a:pPr algn="l"/>
             <a:r>
-              <a:rPr sz="1100" b="1">
+              <a:rPr sz="2000" b="1" dirty="0">
                 <a:solidFill>
                   <a:srgbClr val="1C1717"/>
                 </a:solidFill>
@@ -5412,18 +5636,18 @@
               <a:t>•  TF-IDF</a:t>
             </a:r>
             <a:r>
-              <a:rPr sz="1000">
-                <a:solidFill>
-                  <a:srgbClr val="78716C"/>
-                </a:solidFill>
-              </a:rPr>
-              <a:t>  — word + char n-grams, sublinear TF</a:t>
+              <a:rPr sz="2000" dirty="0">
+                <a:solidFill>
+                  <a:srgbClr val="78716C"/>
+                </a:solidFill>
+              </a:rPr>
+              <a:t>  word + char n-grams, sublinear TF</a:t>
             </a:r>
           </a:p>
           <a:p>
             <a:pPr algn="l"/>
             <a:r>
-              <a:rPr sz="1100" b="1">
+              <a:rPr sz="2000" b="1" dirty="0">
                 <a:solidFill>
                   <a:srgbClr val="1C1717"/>
                 </a:solidFill>
@@ -5431,18 +5655,18 @@
               <a:t>•  BM25 Okapi</a:t>
             </a:r>
             <a:r>
-              <a:rPr sz="1000">
-                <a:solidFill>
-                  <a:srgbClr val="78716C"/>
-                </a:solidFill>
-              </a:rPr>
-              <a:t>  — Lucene-style smoothed IDF</a:t>
+              <a:rPr sz="2000" dirty="0">
+                <a:solidFill>
+                  <a:srgbClr val="78716C"/>
+                </a:solidFill>
+              </a:rPr>
+              <a:t>  Lucene-style smoothed IDF</a:t>
             </a:r>
           </a:p>
           <a:p>
             <a:pPr algn="l"/>
             <a:r>
-              <a:rPr sz="1100" b="1">
+              <a:rPr sz="2000" b="1" dirty="0">
                 <a:solidFill>
                   <a:srgbClr val="1C1717"/>
                 </a:solidFill>
@@ -5450,18 +5674,18 @@
               <a:t>•  Naive Bayes</a:t>
             </a:r>
             <a:r>
-              <a:rPr sz="1000">
-                <a:solidFill>
-                  <a:srgbClr val="78716C"/>
-                </a:solidFill>
-              </a:rPr>
-              <a:t>  — Laplace smoothing</a:t>
+              <a:rPr sz="2000" dirty="0">
+                <a:solidFill>
+                  <a:srgbClr val="78716C"/>
+                </a:solidFill>
+              </a:rPr>
+              <a:t>  Laplace smoothing</a:t>
             </a:r>
           </a:p>
           <a:p>
             <a:pPr algn="l"/>
             <a:r>
-              <a:rPr sz="1100" b="1">
+              <a:rPr sz="2000" b="1" dirty="0">
                 <a:solidFill>
                   <a:srgbClr val="1C1717"/>
                 </a:solidFill>
@@ -5469,37 +5693,53 @@
               <a:t>•  Logistic Reg.</a:t>
             </a:r>
             <a:r>
-              <a:rPr sz="1000">
-                <a:solidFill>
-                  <a:srgbClr val="78716C"/>
-                </a:solidFill>
-              </a:rPr>
-              <a:t>  — batch GD + L2 + class weights</a:t>
+              <a:rPr sz="2000" dirty="0">
+                <a:solidFill>
+                  <a:srgbClr val="78716C"/>
+                </a:solidFill>
+              </a:rPr>
+              <a:t>  batch GD + L2 + class weights</a:t>
             </a:r>
           </a:p>
           <a:p>
             <a:pPr algn="l"/>
             <a:r>
-              <a:rPr sz="1100" b="1">
+              <a:rPr sz="2000" b="1" dirty="0">
                 <a:solidFill>
                   <a:srgbClr val="1C1717"/>
                 </a:solidFill>
               </a:rPr>
-              <a:t>•  Randomised SVD</a:t>
-            </a:r>
-            <a:r>
-              <a:rPr sz="1000">
-                <a:solidFill>
-                  <a:srgbClr val="78716C"/>
-                </a:solidFill>
-              </a:rPr>
-              <a:t>  — Halko-Martinsson-Tropp 2011</a:t>
+              <a:t>•  </a:t>
+            </a:r>
+            <a:r>
+              <a:rPr sz="2000" b="1" dirty="0" err="1">
+                <a:solidFill>
+                  <a:srgbClr val="1C1717"/>
+                </a:solidFill>
+              </a:rPr>
+              <a:t>Randomised</a:t>
+            </a:r>
+            <a:r>
+              <a:rPr sz="2000" b="1" dirty="0">
+                <a:solidFill>
+                  <a:srgbClr val="1C1717"/>
+                </a:solidFill>
+              </a:rPr>
+              <a:t> SVD</a:t>
+            </a:r>
+            <a:r>
+              <a:rPr sz="2000" dirty="0">
+                <a:solidFill>
+                  <a:srgbClr val="78716C"/>
+                </a:solidFill>
+              </a:rPr>
+              <a:t>  Halko-Martinsson-Tropp 2011</a:t>
             </a:r>
           </a:p>
           <a:p>
             <a:pPr algn="l"/>
             <a:r>
-              <a:rPr sz="1100" b="1">
+              <a:rPr sz="2000" b="1" dirty="0">
                 <a:solidFill>
                   <a:srgbClr val="1C1717"/>
                 </a:solidFill>
@@ -5507,18 +5747,31 @@
               <a:t>•  K-Means</a:t>
             </a:r>
             <a:r>
-              <a:rPr sz="1000">
-                <a:solidFill>
-                  <a:srgbClr val="78716C"/>
-                </a:solidFill>
-              </a:rPr>
-              <a:t>  — k-means++ init</a:t>
-            </a:r>
+              <a:rPr sz="2000" dirty="0">
+                <a:solidFill>
+                  <a:srgbClr val="78716C"/>
+                </a:solidFill>
+              </a:rPr>
+              <a:t>  k-means++ </a:t>
+            </a:r>
+            <a:r>
+              <a:rPr sz="2000" dirty="0" err="1">
+                <a:solidFill>
+                  <a:srgbClr val="78716C"/>
+                </a:solidFill>
+              </a:rPr>
+              <a:t>init</a:t>
+            </a:r>
+            <a:endParaRPr sz="2000" dirty="0">
+              <a:solidFill>
+                <a:srgbClr val="78716C"/>
+              </a:solidFill>
+            </a:endParaRPr>
           </a:p>
           <a:p>
             <a:pPr algn="l"/>
             <a:r>
-              <a:rPr sz="1100" b="1">
+              <a:rPr sz="2000" b="1" dirty="0">
                 <a:solidFill>
                   <a:srgbClr val="1C1717"/>
                 </a:solidFill>
@@ -5526,18 +5779,50 @@
               <a:t>•  MLP + backprop</a:t>
             </a:r>
             <a:r>
-              <a:rPr sz="1000">
-                <a:solidFill>
-                  <a:srgbClr val="78716C"/>
-                </a:solidFill>
-              </a:rPr>
-              <a:t>  — ReLU/softmax, momentum SGD</a:t>
+              <a:rPr sz="2000" dirty="0">
+                <a:solidFill>
+                  <a:srgbClr val="78716C"/>
+                </a:solidFill>
+              </a:rPr>
+              <a:t>  </a:t>
+            </a:r>
+            <a:r>
+              <a:rPr sz="2000" dirty="0" err="1">
+                <a:solidFill>
+                  <a:srgbClr val="78716C"/>
+                </a:solidFill>
+              </a:rPr>
+              <a:t>ReLU</a:t>
+            </a:r>
+            <a:r>
+              <a:rPr sz="2000" dirty="0">
+                <a:solidFill>
+                  <a:srgbClr val="78716C"/>
+                </a:solidFill>
+              </a:rPr>
+              <a:t>/</a:t>
+            </a:r>
+            <a:r>
+              <a:rPr sz="2000" dirty="0" err="1">
+                <a:solidFill>
+                  <a:srgbClr val="78716C"/>
+                </a:solidFill>
+              </a:rPr>
+              <a:t>softmax</a:t>
+            </a:r>
+            <a:r>
+              <a:rPr sz="2000" dirty="0">
+                <a:solidFill>
+                  <a:srgbClr val="78716C"/>
+                </a:solidFill>
+              </a:rPr>
+              <a:t>, momentum SGD</a:t>
             </a:r>
           </a:p>
           <a:p>
             <a:pPr algn="l"/>
             <a:r>
-              <a:rPr sz="1100" b="1">
+              <a:rPr sz="2000" b="1" dirty="0">
                 <a:solidFill>
                   <a:srgbClr val="1C1717"/>
                 </a:solidFill>
@@ -5545,18 +5830,18 @@
               <a:t>•  CRF</a:t>
             </a:r>
             <a:r>
-              <a:rPr sz="1000">
-                <a:solidFill>
-                  <a:srgbClr val="78716C"/>
-                </a:solidFill>
-              </a:rPr>
-              <a:t>  — forward-backward + Viterbi</a:t>
+              <a:rPr sz="2000" dirty="0">
+                <a:solidFill>
+                  <a:srgbClr val="78716C"/>
+                </a:solidFill>
+              </a:rPr>
+              <a:t>  forward-backward + Viterbi</a:t>
             </a:r>
           </a:p>
           <a:p>
             <a:pPr algn="l"/>
             <a:r>
-              <a:rPr sz="1100" b="1">
+              <a:rPr sz="2000" b="1" dirty="0">
                 <a:solidFill>
                   <a:srgbClr val="1C1717"/>
                 </a:solidFill>
@@ -5564,18 +5849,18 @@
               <a:t>•  Word2Vec</a:t>
             </a:r>
             <a:r>
-              <a:rPr sz="1000">
-                <a:solidFill>
-                  <a:srgbClr val="78716C"/>
-                </a:solidFill>
-              </a:rPr>
-              <a:t>  — skip-gram + neg sampling</a:t>
+              <a:rPr sz="2000" dirty="0">
+                <a:solidFill>
+                  <a:srgbClr val="78716C"/>
+                </a:solidFill>
+              </a:rPr>
+              <a:t>  skip-gram + neg sampling</a:t>
             </a:r>
           </a:p>
           <a:p>
             <a:pPr algn="l"/>
             <a:r>
-              <a:rPr sz="1100" b="1">
+              <a:rPr sz="2000" b="1" dirty="0">
                 <a:solidFill>
                   <a:srgbClr val="1C1717"/>
                 </a:solidFill>
@@ -5583,18 +5868,34 @@
               <a:t>•  Dual encoder</a:t>
             </a:r>
             <a:r>
-              <a:rPr sz="1000">
-                <a:solidFill>
-                  <a:srgbClr val="78716C"/>
-                </a:solidFill>
-              </a:rPr>
-              <a:t>  — InfoNCE bi-encoder</a:t>
+              <a:rPr sz="2000" dirty="0">
+                <a:solidFill>
+                  <a:srgbClr val="78716C"/>
+                </a:solidFill>
+              </a:rPr>
+              <a:t>  </a:t>
+            </a:r>
+            <a:r>
+              <a:rPr sz="2000" dirty="0" err="1">
+                <a:solidFill>
+                  <a:srgbClr val="78716C"/>
+                </a:solidFill>
+              </a:rPr>
+              <a:t>InfoNCE</a:t>
+            </a:r>
+            <a:r>
+              <a:rPr sz="2000" dirty="0">
+                <a:solidFill>
+                  <a:srgbClr val="78716C"/>
+                </a:solidFill>
+              </a:rPr>
+              <a:t> bi-encoder</a:t>
             </a:r>
           </a:p>
           <a:p>
             <a:pPr algn="l"/>
             <a:r>
-              <a:rPr sz="1100" b="1">
+              <a:rPr sz="2000" b="1" dirty="0">
                 <a:solidFill>
                   <a:srgbClr val="1C1717"/>
                 </a:solidFill>
@@ -5602,278 +5903,12 @@
               <a:t>•  BPE tokenizer</a:t>
             </a:r>
             <a:r>
-              <a:rPr sz="1000">
-                <a:solidFill>
-                  <a:srgbClr val="78716C"/>
-                </a:solidFill>
-              </a:rPr>
-              <a:t>  — Sennrich 2016</a:t>
-            </a:r>
-          </a:p>
-        </p:txBody>
-      </p:sp>
-      <p:sp>
-        <p:nvSpPr>
-          <p:cNvPr id="6" name="TextBox 5"/>
-          <p:cNvSpPr txBox="1"/>
-          <p:nvPr/>
-        </p:nvSpPr>
-        <p:spPr>
-          <a:xfrm>
-            <a:off x="6217920" y="1097280"/>
-            <a:ext cx="5486400" cy="365760"/>
-          </a:xfrm>
-          <a:prstGeom prst="rect">
-            <a:avLst/>
-          </a:prstGeom>
-          <a:noFill/>
-        </p:spPr>
-        <p:txBody>
-          <a:bodyPr wrap="square" lIns="0" tIns="0" rIns="0" bIns="0">
-            <a:spAutoFit/>
-          </a:bodyPr>
-          <a:lstStyle/>
-          <a:p>
-            <a:pPr algn="l"/>
-            <a:r>
-              <a:rPr sz="1500" b="1">
-                <a:solidFill>
-                  <a:srgbClr val="1C1717"/>
-                </a:solidFill>
-              </a:rPr>
-              <a:t>Trainable transformer (PyTorch, GPU)</a:t>
-            </a:r>
-          </a:p>
-        </p:txBody>
-      </p:sp>
-      <p:sp>
-        <p:nvSpPr>
-          <p:cNvPr id="7" name="TextBox 6"/>
-          <p:cNvSpPr txBox="1"/>
-          <p:nvPr/>
-        </p:nvSpPr>
-        <p:spPr>
-          <a:xfrm>
-            <a:off x="6263640" y="1463040"/>
-            <a:ext cx="5486400" cy="4572000"/>
-          </a:xfrm>
-          <a:prstGeom prst="rect">
-            <a:avLst/>
-          </a:prstGeom>
-          <a:noFill/>
-        </p:spPr>
-        <p:txBody>
-          <a:bodyPr wrap="square">
-            <a:spAutoFit/>
-          </a:bodyPr>
-          <a:lstStyle/>
-          <a:p>
-            <a:pPr algn="l"/>
-            <a:r>
-              <a:rPr sz="1100" b="1">
-                <a:solidFill>
-                  <a:srgbClr val="1C1717"/>
-                </a:solidFill>
-              </a:rPr>
-              <a:t>•  Backend</a:t>
-            </a:r>
-            <a:r>
-              <a:rPr sz="1000">
-                <a:solidFill>
-                  <a:srgbClr val="78716C"/>
-                </a:solidFill>
-              </a:rPr>
-              <a:t>  — PyTorch tensors + autograd only</a:t>
-            </a:r>
-          </a:p>
-          <a:p>
-            <a:pPr algn="l"/>
-            <a:r>
-              <a:rPr sz="1100" b="1">
-                <a:solidFill>
-                  <a:srgbClr val="1C1717"/>
-                </a:solidFill>
-              </a:rPr>
-              <a:t>•  No pretrained weights</a:t>
-            </a:r>
-            <a:r>
-              <a:rPr sz="1000">
-                <a:solidFill>
-                  <a:srgbClr val="78716C"/>
-                </a:solidFill>
-              </a:rPr>
-              <a:t>  — every layer written by us</a:t>
-            </a:r>
-          </a:p>
-          <a:p>
-            <a:pPr algn="l"/>
-            <a:r>
-              <a:rPr sz="1100" b="1">
-                <a:solidFill>
-                  <a:srgbClr val="1C1717"/>
-                </a:solidFill>
-              </a:rPr>
-              <a:t>•  Arch.</a:t>
-            </a:r>
-            <a:r>
-              <a:rPr sz="1000">
-                <a:solidFill>
-                  <a:srgbClr val="78716C"/>
-                </a:solidFill>
-              </a:rPr>
-              <a:t>  — 2 encoder blocks · 4 heads · d=64 · d_ff=128</a:t>
-            </a:r>
-          </a:p>
-          <a:p>
-            <a:pPr algn="l"/>
-            <a:r>
-              <a:rPr sz="1100" b="1">
-                <a:solidFill>
-                  <a:srgbClr val="1C1717"/>
-                </a:solidFill>
-              </a:rPr>
-              <a:t>•  Embedding</a:t>
-            </a:r>
-            <a:r>
-              <a:rPr sz="1000">
-                <a:solidFill>
-                  <a:srgbClr val="78716C"/>
-                </a:solidFill>
-              </a:rPr>
-              <a:t>  — vocab-id → 64-d + sinusoidal pos enc</a:t>
-            </a:r>
-          </a:p>
-          <a:p>
-            <a:pPr algn="l"/>
-            <a:r>
-              <a:rPr sz="1100" b="1">
-                <a:solidFill>
-                  <a:srgbClr val="1C1717"/>
-                </a:solidFill>
-              </a:rPr>
-              <a:t>•  Attention</a:t>
-            </a:r>
-            <a:r>
-              <a:rPr sz="1000">
-                <a:solidFill>
-                  <a:srgbClr val="78716C"/>
-                </a:solidFill>
-              </a:rPr>
-              <a:t>  — scaled dot-product · multi-head · pre-LN</a:t>
-            </a:r>
-          </a:p>
-          <a:p>
-            <a:pPr algn="l"/>
-            <a:r>
-              <a:rPr sz="1100" b="1">
-                <a:solidFill>
-                  <a:srgbClr val="1C1717"/>
-                </a:solidFill>
-              </a:rPr>
-              <a:t>•  Pool / head</a:t>
-            </a:r>
-            <a:r>
-              <a:rPr sz="1000">
-                <a:solidFill>
-                  <a:srgbClr val="78716C"/>
-                </a:solidFill>
-              </a:rPr>
-              <a:t>  — masked mean-pool → softmax(13 classes)</a:t>
-            </a:r>
-          </a:p>
-          <a:p>
-            <a:pPr algn="l"/>
-            <a:r>
-              <a:rPr sz="1100" b="1">
-                <a:solidFill>
-                  <a:srgbClr val="1C1717"/>
-                </a:solidFill>
-              </a:rPr>
-              <a:t>•  Training data</a:t>
-            </a:r>
-            <a:r>
-              <a:rPr sz="1000">
-                <a:solidFill>
-                  <a:srgbClr val="78716C"/>
-                </a:solidFill>
-              </a:rPr>
-              <a:t>  — 1206 augmented intent examples</a:t>
-            </a:r>
-          </a:p>
-          <a:p>
-            <a:pPr algn="l"/>
-            <a:r>
-              <a:rPr sz="1100" b="1">
-                <a:solidFill>
-                  <a:srgbClr val="1C1717"/>
-                </a:solidFill>
-              </a:rPr>
-              <a:t>•  Optimiser</a:t>
-            </a:r>
-            <a:r>
-              <a:rPr sz="1000">
-                <a:solidFill>
-                  <a:srgbClr val="78716C"/>
-                </a:solidFill>
-              </a:rPr>
-              <a:t>  — AdamW + cosine LR + grad clip</a:t>
-            </a:r>
-          </a:p>
-          <a:p>
-            <a:pPr algn="l"/>
-            <a:r>
-              <a:rPr sz="1100" b="1">
-                <a:solidFill>
-                  <a:srgbClr val="1C1717"/>
-                </a:solidFill>
-              </a:rPr>
-              <a:t>•  Hardware</a:t>
-            </a:r>
-            <a:r>
-              <a:rPr sz="1000">
-                <a:solidFill>
-                  <a:srgbClr val="78716C"/>
-                </a:solidFill>
-              </a:rPr>
-              <a:t>  — Auto-detects CUDA; CPU fallback</a:t>
-            </a:r>
-          </a:p>
-          <a:p>
-            <a:pPr algn="l"/>
-            <a:r>
-              <a:rPr sz="1100" b="1">
-                <a:solidFill>
-                  <a:srgbClr val="1C1717"/>
-                </a:solidFill>
-              </a:rPr>
-              <a:t>•  Result</a:t>
-            </a:r>
-            <a:r>
-              <a:rPr sz="1000">
-                <a:solidFill>
-                  <a:srgbClr val="78716C"/>
-                </a:solidFill>
-              </a:rPr>
-              <a:t>  — train acc 1.000, loss 0.0003</a:t>
-            </a:r>
-          </a:p>
-          <a:p>
-            <a:pPr algn="l"/>
-            <a:r>
-              <a:rPr sz="1100" b="1">
-                <a:solidFill>
-                  <a:srgbClr val="1C1717"/>
-                </a:solidFill>
-              </a:rPr>
-              <a:t>•  Endpoint</a:t>
-            </a:r>
-            <a:r>
-              <a:rPr sz="1000">
-                <a:solidFill>
-                  <a:srgbClr val="78716C"/>
-                </a:solidFill>
-              </a:rPr>
-              <a:t>  — POST /nlp/torch_intent</a:t>
+              <a:rPr sz="2000" dirty="0">
+                <a:solidFill>
+                  <a:srgbClr val="78716C"/>
+                </a:solidFill>
+              </a:rPr>
+              <a:t>  Sennrich 2016</a:t>
             </a:r>
           </a:p>
         </p:txBody>
@@ -6021,11 +6056,17 @@
           <p:cNvGraphicFramePr>
             <a:graphicFrameLocks noGrp="1"/>
           </p:cNvGraphicFramePr>
-          <p:nvPr/>
+          <p:nvPr>
+            <p:extLst>
+              <p:ext uri="{D42A27DB-BD31-4B8C-83A1-F6EECF244321}">
+                <p14:modId xmlns:p14="http://schemas.microsoft.com/office/powerpoint/2010/main" val="4211574480"/>
+              </p:ext>
+            </p:extLst>
+          </p:nvPr>
         </p:nvGraphicFramePr>
         <p:xfrm>
           <a:off x="457200" y="1783080"/>
-          <a:ext cx="3657600" cy="2103120"/>
+          <a:ext cx="3657600" cy="2377440"/>
         </p:xfrm>
         <a:graphic>
           <a:graphicData uri="http://schemas.openxmlformats.org/drawingml/2006/table">
@@ -6056,7 +6097,7 @@
                     <a:lstStyle/>
                     <a:p>
                       <a:r>
-                        <a:rPr sz="1200" b="1">
+                        <a:rPr sz="2000" b="1">
                           <a:solidFill>
                             <a:srgbClr val="1C1717"/>
                           </a:solidFill>
@@ -6073,7 +6114,7 @@
                     <a:lstStyle/>
                     <a:p>
                       <a:r>
-                        <a:rPr sz="1200" b="1">
+                        <a:rPr sz="2000" b="1">
                           <a:solidFill>
                             <a:srgbClr val="1C1717"/>
                           </a:solidFill>
@@ -6097,7 +6138,7 @@
                     <a:lstStyle/>
                     <a:p>
                       <a:r>
-                        <a:rPr sz="1200">
+                        <a:rPr sz="2000">
                           <a:solidFill>
                             <a:srgbClr val="1C1717"/>
                           </a:solidFill>
@@ -6114,7 +6155,7 @@
                     <a:lstStyle/>
                     <a:p>
                       <a:r>
-                        <a:rPr sz="1200">
+                        <a:rPr sz="2000">
                           <a:solidFill>
                             <a:srgbClr val="1C1717"/>
                           </a:solidFill>
@@ -6138,7 +6179,7 @@
                     <a:lstStyle/>
                     <a:p>
                       <a:r>
-                        <a:rPr sz="1200">
+                        <a:rPr sz="2000" dirty="0">
                           <a:solidFill>
                             <a:srgbClr val="1C1717"/>
                           </a:solidFill>
@@ -6155,7 +6196,7 @@
                     <a:lstStyle/>
                     <a:p>
                       <a:r>
-                        <a:rPr sz="1200">
+                        <a:rPr sz="2000">
                           <a:solidFill>
                             <a:srgbClr val="1C1717"/>
                           </a:solidFill>
@@ -6179,7 +6220,7 @@
                     <a:lstStyle/>
                     <a:p>
                       <a:r>
-                        <a:rPr sz="1200">
+                        <a:rPr sz="2000" dirty="0">
                           <a:solidFill>
                             <a:srgbClr val="1C1717"/>
                           </a:solidFill>
@@ -6196,7 +6237,7 @@
                     <a:lstStyle/>
                     <a:p>
                       <a:r>
-                        <a:rPr sz="1200">
+                        <a:rPr sz="2000">
                           <a:solidFill>
                             <a:srgbClr val="1C1717"/>
                           </a:solidFill>
@@ -6220,7 +6261,7 @@
                     <a:lstStyle/>
                     <a:p>
                       <a:r>
-                        <a:rPr sz="1200">
+                        <a:rPr sz="2000" dirty="0">
                           <a:solidFill>
                             <a:srgbClr val="1C1717"/>
                           </a:solidFill>
@@ -6237,7 +6278,7 @@
                     <a:lstStyle/>
                     <a:p>
                       <a:r>
-                        <a:rPr sz="1200">
+                        <a:rPr sz="2000">
                           <a:solidFill>
                             <a:srgbClr val="1C1717"/>
                           </a:solidFill>
@@ -6261,7 +6302,7 @@
                     <a:lstStyle/>
                     <a:p>
                       <a:r>
-                        <a:rPr sz="1200">
+                        <a:rPr sz="2000" dirty="0">
                           <a:solidFill>
                             <a:srgbClr val="1C1717"/>
                           </a:solidFill>
@@ -6278,13 +6319,26 @@
                     <a:lstStyle/>
                     <a:p>
                       <a:r>
-                        <a:rPr sz="1200">
+                        <a:rPr sz="2000" dirty="0">
                           <a:solidFill>
                             <a:srgbClr val="1C1717"/>
                           </a:solidFill>
                         </a:rPr>
-                        <a:t>47 ms</a:t>
+                        <a:t>47 </a:t>
                       </a:r>
+                      <a:r>
+                        <a:rPr sz="2000" dirty="0" err="1">
+                          <a:solidFill>
+                            <a:srgbClr val="1C1717"/>
+                          </a:solidFill>
+                        </a:rPr>
+                        <a:t>ms</a:t>
+                      </a:r>
+                      <a:endParaRPr sz="2000" dirty="0">
+                        <a:solidFill>
+                          <a:srgbClr val="1C1717"/>
+                        </a:solidFill>
+                      </a:endParaRPr>
                     </a:p>
                   </a:txBody>
                   <a:tcPr/>
@@ -6305,11 +6359,17 @@
           <p:cNvGraphicFramePr>
             <a:graphicFrameLocks noGrp="1"/>
           </p:cNvGraphicFramePr>
-          <p:nvPr/>
+          <p:nvPr>
+            <p:extLst>
+              <p:ext uri="{D42A27DB-BD31-4B8C-83A1-F6EECF244321}">
+                <p14:modId xmlns:p14="http://schemas.microsoft.com/office/powerpoint/2010/main" val="2247486212"/>
+              </p:ext>
+            </p:extLst>
+          </p:nvPr>
         </p:nvGraphicFramePr>
         <p:xfrm>
-          <a:off x="4480560" y="1783080"/>
-          <a:ext cx="7315200" cy="2103120"/>
+          <a:off x="4191000" y="1783080"/>
+          <a:ext cx="7810500" cy="2103120"/>
         </p:xfrm>
         <a:graphic>
           <a:graphicData uri="http://schemas.openxmlformats.org/drawingml/2006/table">
@@ -6318,35 +6378,35 @@
                 <a:tableStyleId>{5C22544A-7EE6-4342-B048-85BDC9FD1C3A}</a:tableStyleId>
               </a:tblPr>
               <a:tblGrid>
-                <a:gridCol w="1463040">
+                <a:gridCol w="1783080">
                   <a:extLst>
                     <a:ext uri="{9D8B030D-6E8A-4147-A177-3AD203B41FA5}">
                       <a16:colId xmlns:a16="http://schemas.microsoft.com/office/drawing/2014/main" val="20000"/>
                     </a:ext>
                   </a:extLst>
                 </a:gridCol>
-                <a:gridCol w="1463040">
+                <a:gridCol w="1341120">
                   <a:extLst>
                     <a:ext uri="{9D8B030D-6E8A-4147-A177-3AD203B41FA5}">
                       <a16:colId xmlns:a16="http://schemas.microsoft.com/office/drawing/2014/main" val="20001"/>
                     </a:ext>
                   </a:extLst>
                 </a:gridCol>
-                <a:gridCol w="1463040">
+                <a:gridCol w="1562100">
                   <a:extLst>
                     <a:ext uri="{9D8B030D-6E8A-4147-A177-3AD203B41FA5}">
                       <a16:colId xmlns:a16="http://schemas.microsoft.com/office/drawing/2014/main" val="20002"/>
                     </a:ext>
                   </a:extLst>
                 </a:gridCol>
-                <a:gridCol w="1463040">
+                <a:gridCol w="1562100">
                   <a:extLst>
                     <a:ext uri="{9D8B030D-6E8A-4147-A177-3AD203B41FA5}">
                       <a16:colId xmlns:a16="http://schemas.microsoft.com/office/drawing/2014/main" val="20003"/>
                     </a:ext>
                   </a:extLst>
                 </a:gridCol>
-                <a:gridCol w="1463040">
+                <a:gridCol w="1562100">
                   <a:extLst>
                     <a:ext uri="{9D8B030D-6E8A-4147-A177-3AD203B41FA5}">
                       <a16:colId xmlns:a16="http://schemas.microsoft.com/office/drawing/2014/main" val="20004"/>
@@ -6361,7 +6421,7 @@
                     <a:lstStyle/>
                     <a:p>
                       <a:r>
-                        <a:rPr sz="1200" b="1">
+                        <a:rPr sz="2000" b="1">
                           <a:solidFill>
                             <a:srgbClr val="1C1717"/>
                           </a:solidFill>
@@ -6378,7 +6438,7 @@
                     <a:lstStyle/>
                     <a:p>
                       <a:r>
-                        <a:rPr sz="1200" b="1">
+                        <a:rPr sz="2000" b="1">
                           <a:solidFill>
                             <a:srgbClr val="1C1717"/>
                           </a:solidFill>
@@ -6395,7 +6455,7 @@
                     <a:lstStyle/>
                     <a:p>
                       <a:r>
-                        <a:rPr sz="1200" b="1">
+                        <a:rPr sz="2000" b="1">
                           <a:solidFill>
                             <a:srgbClr val="1C1717"/>
                           </a:solidFill>
@@ -6412,7 +6472,7 @@
                     <a:lstStyle/>
                     <a:p>
                       <a:r>
-                        <a:rPr sz="1200" b="1">
+                        <a:rPr sz="2000" b="1">
                           <a:solidFill>
                             <a:srgbClr val="1C1717"/>
                           </a:solidFill>
@@ -6429,7 +6489,7 @@
                     <a:lstStyle/>
                     <a:p>
                       <a:r>
-                        <a:rPr sz="1200" b="1">
+                        <a:rPr sz="2000" b="1">
                           <a:solidFill>
                             <a:srgbClr val="1C1717"/>
                           </a:solidFill>
@@ -6453,7 +6513,7 @@
                     <a:lstStyle/>
                     <a:p>
                       <a:r>
-                        <a:rPr sz="1200">
+                        <a:rPr sz="2000">
                           <a:solidFill>
                             <a:srgbClr val="1C1717"/>
                           </a:solidFill>
@@ -6470,7 +6530,7 @@
                     <a:lstStyle/>
                     <a:p>
                       <a:r>
-                        <a:rPr sz="1200">
+                        <a:rPr sz="2000">
                           <a:solidFill>
                             <a:srgbClr val="1C1717"/>
                           </a:solidFill>
@@ -6487,7 +6547,7 @@
                     <a:lstStyle/>
                     <a:p>
                       <a:r>
-                        <a:rPr sz="1200">
+                        <a:rPr sz="2000">
                           <a:solidFill>
                             <a:srgbClr val="1C1717"/>
                           </a:solidFill>
@@ -6504,7 +6564,7 @@
                     <a:lstStyle/>
                     <a:p>
                       <a:r>
-                        <a:rPr sz="1200">
+                        <a:rPr sz="2000">
                           <a:solidFill>
                             <a:srgbClr val="1C1717"/>
                           </a:solidFill>
@@ -6521,7 +6581,7 @@
                     <a:lstStyle/>
                     <a:p>
                       <a:r>
-                        <a:rPr sz="1200">
+                        <a:rPr sz="2000">
                           <a:solidFill>
                             <a:srgbClr val="1C1717"/>
                           </a:solidFill>
@@ -6545,7 +6605,7 @@
                     <a:lstStyle/>
                     <a:p>
                       <a:r>
-                        <a:rPr sz="1200">
+                        <a:rPr sz="2000">
                           <a:solidFill>
                             <a:srgbClr val="1C1717"/>
                           </a:solidFill>
@@ -6562,7 +6622,7 @@
                     <a:lstStyle/>
                     <a:p>
                       <a:r>
-                        <a:rPr sz="1200">
+                        <a:rPr sz="2000">
                           <a:solidFill>
                             <a:srgbClr val="1C1717"/>
                           </a:solidFill>
@@ -6579,7 +6639,7 @@
                     <a:lstStyle/>
                     <a:p>
                       <a:r>
-                        <a:rPr sz="1200">
+                        <a:rPr sz="2000">
                           <a:solidFill>
                             <a:srgbClr val="1C1717"/>
                           </a:solidFill>
@@ -6596,7 +6656,7 @@
                     <a:lstStyle/>
                     <a:p>
                       <a:r>
-                        <a:rPr sz="1200">
+                        <a:rPr sz="2000">
                           <a:solidFill>
                             <a:srgbClr val="1C1717"/>
                           </a:solidFill>
@@ -6613,7 +6673,7 @@
                     <a:lstStyle/>
                     <a:p>
                       <a:r>
-                        <a:rPr sz="1200">
+                        <a:rPr sz="2000">
                           <a:solidFill>
                             <a:srgbClr val="1C1717"/>
                           </a:solidFill>
@@ -6637,7 +6697,7 @@
                     <a:lstStyle/>
                     <a:p>
                       <a:r>
-                        <a:rPr sz="1200">
+                        <a:rPr sz="2000">
                           <a:solidFill>
                             <a:srgbClr val="1C1717"/>
                           </a:solidFill>
@@ -6654,7 +6714,7 @@
                     <a:lstStyle/>
                     <a:p>
                       <a:r>
-                        <a:rPr sz="1200">
+                        <a:rPr sz="2000">
                           <a:solidFill>
                             <a:srgbClr val="1C1717"/>
                           </a:solidFill>
@@ -6671,7 +6731,7 @@
                     <a:lstStyle/>
                     <a:p>
                       <a:r>
-                        <a:rPr sz="1200">
+                        <a:rPr sz="2000">
                           <a:solidFill>
                             <a:srgbClr val="1C1717"/>
                           </a:solidFill>
@@ -6688,7 +6748,7 @@
                     <a:lstStyle/>
                     <a:p>
                       <a:r>
-                        <a:rPr sz="1200">
+                        <a:rPr sz="2000">
                           <a:solidFill>
                             <a:srgbClr val="1C1717"/>
                           </a:solidFill>
@@ -6705,7 +6765,7 @@
                     <a:lstStyle/>
                     <a:p>
                       <a:r>
-                        <a:rPr sz="1200">
+                        <a:rPr sz="2000" dirty="0">
                           <a:solidFill>
                             <a:srgbClr val="1C1717"/>
                           </a:solidFill>
@@ -6728,14 +6788,20 @@
       </p:graphicFrame>
       <p:sp>
         <p:nvSpPr>
-          <p:cNvPr id="7" name="TextBox 6"/>
+          <p:cNvPr id="7" name="TextBox 6">
+            <a:extLst>
+              <a:ext uri="{FF2B5EF4-FFF2-40B4-BE49-F238E27FC236}">
+                <a16:creationId xmlns:a16="http://schemas.microsoft.com/office/drawing/2014/main" id="{80116DF1-C31E-07FA-1366-4A0A7BE5A14F}"/>
+              </a:ext>
+            </a:extLst>
+          </p:cNvPr>
           <p:cNvSpPr txBox="1"/>
           <p:nvPr/>
         </p:nvSpPr>
         <p:spPr>
           <a:xfrm>
-            <a:off x="457200" y="4206240"/>
-            <a:ext cx="10972800" cy="457200"/>
+            <a:off x="8951976" y="4370832"/>
+            <a:ext cx="2263697" cy="369332"/>
           </a:xfrm>
           <a:prstGeom prst="rect">
             <a:avLst/>
@@ -6743,87 +6809,14 @@
           <a:noFill/>
         </p:spPr>
         <p:txBody>
-          <a:bodyPr wrap="square" lIns="0" tIns="0" rIns="0" bIns="0">
+          <a:bodyPr wrap="none" rtlCol="0">
             <a:spAutoFit/>
           </a:bodyPr>
           <a:lstStyle/>
           <a:p>
-            <a:pPr algn="l"/>
-            <a:r>
-              <a:rPr sz="1400" b="0">
-                <a:solidFill>
-                  <a:srgbClr val="1C1717"/>
-                </a:solidFill>
-              </a:rPr>
-              <a:t>Transformer intent classifier:  train accuracy 1.000 · final CE loss 0.0003 over 40 epochs</a:t>
-            </a:r>
-          </a:p>
-        </p:txBody>
-      </p:sp>
-      <p:sp>
-        <p:nvSpPr>
-          <p:cNvPr id="8" name="TextBox 7"/>
-          <p:cNvSpPr txBox="1"/>
-          <p:nvPr/>
-        </p:nvSpPr>
-        <p:spPr>
-          <a:xfrm>
-            <a:off x="457200" y="4709160"/>
-            <a:ext cx="10972800" cy="457200"/>
-          </a:xfrm>
-          <a:prstGeom prst="rect">
-            <a:avLst/>
-          </a:prstGeom>
-          <a:noFill/>
-        </p:spPr>
-        <p:txBody>
-          <a:bodyPr wrap="square" lIns="0" tIns="0" rIns="0" bIns="0">
-            <a:spAutoFit/>
-          </a:bodyPr>
-          <a:lstStyle/>
-          <a:p>
-            <a:pPr algn="l"/>
-            <a:r>
-              <a:rPr sz="1400" b="0">
-                <a:solidFill>
-                  <a:srgbClr val="1C1717"/>
-                </a:solidFill>
-              </a:rPr>
-              <a:t>Integration suite (api/final_test.py):  62 / 62 PASS  — covers chat, faq, admin, stats, nlp, frontend routes.</a:t>
-            </a:r>
-          </a:p>
-        </p:txBody>
-      </p:sp>
-      <p:sp>
-        <p:nvSpPr>
-          <p:cNvPr id="9" name="TextBox 8"/>
-          <p:cNvSpPr txBox="1"/>
-          <p:nvPr/>
-        </p:nvSpPr>
-        <p:spPr>
-          <a:xfrm>
-            <a:off x="457200" y="5349240"/>
-            <a:ext cx="10972800" cy="457200"/>
-          </a:xfrm>
-          <a:prstGeom prst="rect">
-            <a:avLst/>
-          </a:prstGeom>
-          <a:noFill/>
-        </p:spPr>
-        <p:txBody>
-          <a:bodyPr wrap="square" lIns="0" tIns="0" rIns="0" bIns="0">
-            <a:spAutoFit/>
-          </a:bodyPr>
-          <a:lstStyle/>
-          <a:p>
-            <a:pPr algn="l"/>
-            <a:r>
-              <a:rPr sz="1400" b="0">
-                <a:solidFill>
-                  <a:srgbClr val="1C1717"/>
-                </a:solidFill>
-              </a:rPr>
-              <a:t>Live FAQ counters verified end-to-end:  counts start at 0, increment per match, persist in Mongo.</a:t>
+            <a:r>
+              <a:rPr lang="en-US" dirty="0"/>
+              <a:t>Mean Reciprocal Rank</a:t>
             </a:r>
           </a:p>
         </p:txBody>
@@ -6940,7 +6933,7 @@
         <p:spPr>
           <a:xfrm>
             <a:off x="548640" y="1280160"/>
-            <a:ext cx="11338560" cy="5212080"/>
+            <a:ext cx="11338560" cy="1631216"/>
           </a:xfrm>
           <a:prstGeom prst="rect">
             <a:avLst/>
@@ -6955,153 +6948,109 @@
           <a:p>
             <a:pPr algn="l"/>
             <a:r>
-              <a:rPr sz="1500" b="1">
+              <a:rPr sz="2000" b="1" dirty="0">
                 <a:solidFill>
                   <a:srgbClr val="1C1717"/>
                 </a:solidFill>
               </a:rPr>
-              <a:t>•  No LLM dependency</a:t>
-            </a:r>
-            <a:r>
-              <a:rPr sz="1400">
-                <a:solidFill>
-                  <a:srgbClr val="78716C"/>
-                </a:solidFill>
-              </a:rPr>
-              <a:t>  — reproducible, auditable, no API costs, no hallucinations.</a:t>
+              <a:t>•  Hybrid retrieval works</a:t>
+            </a:r>
+            <a:r>
+              <a:rPr sz="2000" dirty="0">
+                <a:solidFill>
+                  <a:srgbClr val="78716C"/>
+                </a:solidFill>
+              </a:rPr>
+              <a:t>  P@1 0.93 across 116 held-out queries at 22 </a:t>
+            </a:r>
+            <a:r>
+              <a:rPr sz="2000" dirty="0" err="1">
+                <a:solidFill>
+                  <a:srgbClr val="78716C"/>
+                </a:solidFill>
+              </a:rPr>
+              <a:t>ms</a:t>
+            </a:r>
+            <a:r>
+              <a:rPr sz="2000" dirty="0">
+                <a:solidFill>
+                  <a:srgbClr val="78716C"/>
+                </a:solidFill>
+              </a:rPr>
+              <a:t> p50.</a:t>
             </a:r>
           </a:p>
           <a:p>
             <a:pPr algn="l"/>
             <a:r>
-              <a:rPr sz="1500" b="1">
+              <a:rPr sz="2000" b="1" dirty="0">
                 <a:solidFill>
                   <a:srgbClr val="1C1717"/>
                 </a:solidFill>
               </a:rPr>
-              <a:t>•  Every algorithm is ours</a:t>
-            </a:r>
-            <a:r>
-              <a:rPr sz="1400">
-                <a:solidFill>
-                  <a:srgbClr val="78716C"/>
-                </a:solidFill>
-              </a:rPr>
-              <a:t>  — drop-in replacements for sklearn, rank_bm25 and sentence-transformers.</a:t>
+              <a:t>•  Multi-turn dialog</a:t>
+            </a:r>
+            <a:r>
+              <a:rPr sz="2000" dirty="0">
+                <a:solidFill>
+                  <a:srgbClr val="78716C"/>
+                </a:solidFill>
+              </a:rPr>
+              <a:t> coreference, slot filling, topic tracking, triage banner, empathic openers, disambiguation.</a:t>
             </a:r>
           </a:p>
           <a:p>
             <a:pPr algn="l"/>
             <a:r>
-              <a:rPr sz="1500" b="1">
+              <a:rPr sz="2000" b="1" dirty="0">
                 <a:solidFill>
                   <a:srgbClr val="1C1717"/>
                 </a:solidFill>
               </a:rPr>
-              <a:t>•  Hybrid retrieval works</a:t>
-            </a:r>
-            <a:r>
-              <a:rPr sz="1400">
-                <a:solidFill>
-                  <a:srgbClr val="78716C"/>
-                </a:solidFill>
-              </a:rPr>
-              <a:t>  — P@1 0.93 across 116 held-out queries at 22 ms p50.</a:t>
+              <a:t>•  Pakistan-friendly</a:t>
+            </a:r>
+            <a:r>
+              <a:rPr sz="2000" dirty="0">
+                <a:solidFill>
+                  <a:srgbClr val="78716C"/>
+                </a:solidFill>
+              </a:rPr>
+              <a:t> Roman-Urdu phonetic mapping, 1122 emergency wording, PHI scrub at ingest.</a:t>
             </a:r>
           </a:p>
           <a:p>
             <a:pPr algn="l"/>
             <a:r>
-              <a:rPr sz="1500" b="1">
+              <a:rPr sz="2000" b="1" dirty="0">
                 <a:solidFill>
                   <a:srgbClr val="1C1717"/>
                 </a:solidFill>
               </a:rPr>
-              <a:t>•  Multi-turn dialog</a:t>
-            </a:r>
-            <a:r>
-              <a:rPr sz="1400">
-                <a:solidFill>
-                  <a:srgbClr val="78716C"/>
-                </a:solidFill>
-              </a:rPr>
-              <a:t>  — coreference, slot filling, topic tracking, triage banner, empathic openers, disambiguation.</a:t>
-            </a:r>
-          </a:p>
-          <a:p>
-            <a:pPr algn="l"/>
-            <a:r>
-              <a:rPr sz="1500" b="1">
-                <a:solidFill>
-                  <a:srgbClr val="1C1717"/>
-                </a:solidFill>
-              </a:rPr>
-              <a:t>•  Pakistan-friendly</a:t>
-            </a:r>
-            <a:r>
-              <a:rPr sz="1400">
-                <a:solidFill>
-                  <a:srgbClr val="78716C"/>
-                </a:solidFill>
-              </a:rPr>
-              <a:t>  — Roman-Urdu phonetic mapping, 1122 emergency wording, PHI scrub at ingest.</a:t>
-            </a:r>
-          </a:p>
-          <a:p>
-            <a:pPr algn="l"/>
-            <a:r>
-              <a:rPr sz="1500" b="1">
-                <a:solidFill>
-                  <a:srgbClr val="1C1717"/>
-                </a:solidFill>
-              </a:rPr>
-              <a:t>•  One-command deploy</a:t>
-            </a:r>
-            <a:r>
-              <a:rPr sz="1400">
-                <a:solidFill>
-                  <a:srgbClr val="78716C"/>
-                </a:solidFill>
-              </a:rPr>
-              <a:t>  — docker compose up auto-seeds Mongo, builds API + Next.js.</a:t>
-            </a:r>
-          </a:p>
-          <a:p>
-            <a:pPr algn="l"/>
-            <a:r>
-              <a:rPr sz="1500" b="1">
-                <a:solidFill>
-                  <a:srgbClr val="1C1717"/>
-                </a:solidFill>
-              </a:rPr>
               <a:t>•  Real-time analytics</a:t>
             </a:r>
             <a:r>
-              <a:rPr sz="1400">
-                <a:solidFill>
-                  <a:srgbClr val="78716C"/>
-                </a:solidFill>
-              </a:rPr>
-              <a:t>  — FAQ count increments live, persisted in Mongo, surfaced in /admin.</a:t>
-            </a:r>
-          </a:p>
-          <a:p>
-            <a:pPr algn="l"/>
-            <a:r>
-              <a:rPr sz="1500" b="1">
-                <a:solidFill>
-                  <a:srgbClr val="1C1717"/>
-                </a:solidFill>
-              </a:rPr>
-              <a:t>•  Trainable transformer</a:t>
-            </a:r>
-            <a:r>
-              <a:rPr sz="1400">
-                <a:solidFill>
-                  <a:srgbClr val="78716C"/>
-                </a:solidFill>
-              </a:rPr>
-              <a:t>  — GPU-ready PyTorch model trained from scratch on our own corpus.</a:t>
+              <a:rPr sz="2000" dirty="0">
+                <a:solidFill>
+                  <a:srgbClr val="78716C"/>
+                </a:solidFill>
+              </a:rPr>
+              <a:t> FAQ count increments live, </a:t>
+            </a:r>
+            <a:r>
+              <a:rPr lang="en-US" sz="2000" dirty="0">
+                <a:solidFill>
+                  <a:srgbClr val="78716C"/>
+                </a:solidFill>
+              </a:rPr>
+              <a:t>stored</a:t>
+            </a:r>
+            <a:r>
+              <a:rPr sz="2000" dirty="0">
+                <a:solidFill>
+                  <a:srgbClr val="78716C"/>
+                </a:solidFill>
+              </a:rPr>
+              <a:t> in Mongo, surfaced in /admin.</a:t>
             </a:r>
           </a:p>
         </p:txBody>
@@ -7218,7 +7167,7 @@
         <p:spPr>
           <a:xfrm>
             <a:off x="548640" y="1280160"/>
-            <a:ext cx="11338560" cy="5212080"/>
+            <a:ext cx="11338560" cy="3785652"/>
           </a:xfrm>
           <a:prstGeom prst="rect">
             <a:avLst/>
@@ -7233,7 +7182,7 @@
           <a:p>
             <a:pPr algn="l"/>
             <a:r>
-              <a:rPr sz="1500" b="1">
+              <a:rPr sz="2000" b="1" dirty="0">
                 <a:solidFill>
                   <a:srgbClr val="1C1717"/>
                 </a:solidFill>
@@ -7241,18 +7190,50 @@
               <a:t>•  Small corpus</a:t>
             </a:r>
             <a:r>
-              <a:rPr sz="1400">
-                <a:solidFill>
-                  <a:srgbClr val="78716C"/>
-                </a:solidFill>
-              </a:rPr>
-              <a:t>  — 169 FAQs cover the most common questions but out-of-distribution queries fall through to best-guess.</a:t>
+              <a:rPr sz="2000" dirty="0">
+                <a:solidFill>
+                  <a:srgbClr val="78716C"/>
+                </a:solidFill>
+              </a:rPr>
+              <a:t>  </a:t>
+            </a:r>
+            <a:r>
+              <a:rPr lang="en-US" sz="2000" dirty="0">
+                <a:solidFill>
+                  <a:srgbClr val="78716C"/>
+                </a:solidFill>
+              </a:rPr>
+              <a:t>Very less</a:t>
+            </a:r>
+            <a:r>
+              <a:rPr sz="2000" dirty="0">
+                <a:solidFill>
+                  <a:srgbClr val="78716C"/>
+                </a:solidFill>
+              </a:rPr>
+              <a:t> </a:t>
+            </a:r>
+            <a:r>
+              <a:rPr lang="en-US" sz="2000" dirty="0">
+                <a:solidFill>
+                  <a:srgbClr val="78716C"/>
+                </a:solidFill>
+              </a:rPr>
+              <a:t>data </a:t>
+            </a:r>
+            <a:r>
+              <a:rPr sz="2000" dirty="0">
+                <a:solidFill>
+                  <a:srgbClr val="78716C"/>
+                </a:solidFill>
+              </a:rPr>
+              <a:t>cover the most common questions but out-of-distribution queries fall through to best-guess.</a:t>
             </a:r>
           </a:p>
           <a:p>
             <a:pPr algn="l"/>
             <a:r>
-              <a:rPr sz="1500" b="1">
+              <a:rPr sz="2000" b="1" dirty="0">
                 <a:solidFill>
                   <a:srgbClr val="1C1717"/>
                 </a:solidFill>
@@ -7260,18 +7241,18 @@
               <a:t>•  Eval is approximate</a:t>
             </a:r>
             <a:r>
-              <a:rPr sz="1400">
-                <a:solidFill>
-                  <a:srgbClr val="78716C"/>
-                </a:solidFill>
-              </a:rPr>
-              <a:t>  — expected-keyword match in the answer can mark a correct FAQ as wrong when phrasing diverges.</a:t>
+              <a:rPr sz="2000" dirty="0">
+                <a:solidFill>
+                  <a:srgbClr val="78716C"/>
+                </a:solidFill>
+              </a:rPr>
+              <a:t>  expected-keyword match in the answer can mark a correct FAQ as wrong when phrasing diverges.</a:t>
             </a:r>
           </a:p>
           <a:p>
             <a:pPr algn="l"/>
             <a:r>
-              <a:rPr sz="1500" b="1">
+              <a:rPr sz="2000" b="1" dirty="0">
                 <a:solidFill>
                   <a:srgbClr val="1C1717"/>
                 </a:solidFill>
@@ -7279,18 +7260,18 @@
               <a:t>•  Transformer overfits</a:t>
             </a:r>
             <a:r>
-              <a:rPr sz="1400">
-                <a:solidFill>
-                  <a:srgbClr val="78716C"/>
-                </a:solidFill>
-              </a:rPr>
-              <a:t>  — trained on 1206 augmented examples; held-out test of the classifier itself is still small.</a:t>
+              <a:rPr sz="2000" dirty="0">
+                <a:solidFill>
+                  <a:srgbClr val="78716C"/>
+                </a:solidFill>
+              </a:rPr>
+              <a:t>  trained on 1206 augmented examples; held-out test of the classifier itself is still small.</a:t>
             </a:r>
           </a:p>
           <a:p>
             <a:pPr algn="l"/>
             <a:r>
-              <a:rPr sz="1500" b="1">
+              <a:rPr sz="2000" b="1" dirty="0">
                 <a:solidFill>
                   <a:srgbClr val="1C1717"/>
                 </a:solidFill>
@@ -7298,18 +7279,18 @@
               <a:t>•  NER is dictionary-first</a:t>
             </a:r>
             <a:r>
-              <a:rPr sz="1400">
-                <a:solidFill>
-                  <a:srgbClr val="78716C"/>
-                </a:solidFill>
-              </a:rPr>
-              <a:t>  — the CRF + structured perceptron variants improve coverage but training data is only 32 hand-annotated sentences.</a:t>
+              <a:rPr sz="2000" dirty="0">
+                <a:solidFill>
+                  <a:srgbClr val="78716C"/>
+                </a:solidFill>
+              </a:rPr>
+              <a:t>  the CRF + structured perceptron variants improve coverage but training data is only 32 hand-annotated sentences.</a:t>
             </a:r>
           </a:p>
           <a:p>
             <a:pPr algn="l"/>
             <a:r>
-              <a:rPr sz="1500" b="1">
+              <a:rPr sz="2000" b="1" dirty="0">
                 <a:solidFill>
                   <a:srgbClr val="1C1717"/>
                 </a:solidFill>
@@ -7317,18 +7298,18 @@
               <a:t>•  Roman-Urdu is heuristic</a:t>
             </a:r>
             <a:r>
-              <a:rPr sz="1400">
-                <a:solidFill>
-                  <a:srgbClr val="78716C"/>
-                </a:solidFill>
-              </a:rPr>
-              <a:t>  — ~80-word dictionary catches common cases; full transliteration would need a real parallel corpus.</a:t>
+              <a:rPr sz="2000" dirty="0">
+                <a:solidFill>
+                  <a:srgbClr val="78716C"/>
+                </a:solidFill>
+              </a:rPr>
+              <a:t>  ~80-word dictionary catches common cases; full transliteration would need a real parallel corpus.</a:t>
             </a:r>
           </a:p>
           <a:p>
             <a:pPr algn="l"/>
             <a:r>
-              <a:rPr sz="1500" b="1">
+              <a:rPr sz="2000" b="1" dirty="0">
                 <a:solidFill>
                   <a:srgbClr val="1C1717"/>
                 </a:solidFill>
@@ -7336,18 +7317,18 @@
               <a:t>•  Voice input is browser-native</a:t>
             </a:r>
             <a:r>
-              <a:rPr sz="1400">
-                <a:solidFill>
-                  <a:srgbClr val="78716C"/>
-                </a:solidFill>
-              </a:rPr>
-              <a:t>  — Web Speech API works in Chrome / Edge only.</a:t>
+              <a:rPr sz="2000" dirty="0">
+                <a:solidFill>
+                  <a:srgbClr val="78716C"/>
+                </a:solidFill>
+              </a:rPr>
+              <a:t>  Web Speech API works in Chrome / Edge only.</a:t>
             </a:r>
           </a:p>
           <a:p>
             <a:pPr algn="l"/>
             <a:r>
-              <a:rPr sz="1500" b="1">
+              <a:rPr sz="2000" b="1" dirty="0">
                 <a:solidFill>
                   <a:srgbClr val="1C1717"/>
                 </a:solidFill>
@@ -7355,12 +7336,28 @@
               <a:t>•  Counts are at-most-once per turn</a:t>
             </a:r>
             <a:r>
-              <a:rPr sz="1400">
-                <a:solidFill>
-                  <a:srgbClr val="78716C"/>
-                </a:solidFill>
-              </a:rPr>
-              <a:t>  — no fraud / abuse heuristic — every successful match increments.</a:t>
+              <a:rPr sz="2000" dirty="0">
+                <a:solidFill>
+                  <a:srgbClr val="78716C"/>
+                </a:solidFill>
+              </a:rPr>
+              <a:t>  no fraud / abuse heuristic</a:t>
+            </a:r>
+            <a:r>
+              <a:rPr lang="en-US" sz="2000" dirty="0">
+                <a:solidFill>
+                  <a:srgbClr val="78716C"/>
+                </a:solidFill>
+              </a:rPr>
+              <a:t>,</a:t>
+            </a:r>
+            <a:r>
+              <a:rPr sz="2000" dirty="0">
+                <a:solidFill>
+                  <a:srgbClr val="78716C"/>
+                </a:solidFill>
+              </a:rPr>
+              <a:t> every successful match increments.</a:t>
             </a:r>
           </a:p>
         </p:txBody>
@@ -7477,7 +7474,7 @@
         <p:spPr>
           <a:xfrm>
             <a:off x="548640" y="1280160"/>
-            <a:ext cx="11338560" cy="5212080"/>
+            <a:ext cx="11338560" cy="2246769"/>
           </a:xfrm>
           <a:prstGeom prst="rect">
             <a:avLst/>
@@ -7492,7 +7489,7 @@
           <a:p>
             <a:pPr algn="l"/>
             <a:r>
-              <a:rPr sz="1500" b="1">
+              <a:rPr sz="2000" b="1" dirty="0">
                 <a:solidFill>
                   <a:srgbClr val="1C1717"/>
                 </a:solidFill>
@@ -7500,18 +7497,34 @@
               <a:t>•  Grow the corpus</a:t>
             </a:r>
             <a:r>
-              <a:rPr sz="1400">
-                <a:solidFill>
-                  <a:srgbClr val="78716C"/>
-                </a:solidFill>
-              </a:rPr>
-              <a:t>  — 500+ FAQs across more specialties with clinician validation.</a:t>
+              <a:rPr sz="2000" dirty="0">
+                <a:solidFill>
+                  <a:srgbClr val="78716C"/>
+                </a:solidFill>
+              </a:rPr>
+              <a:t>  </a:t>
+            </a:r>
+            <a:r>
+              <a:rPr lang="en-US" sz="2000" dirty="0">
+                <a:solidFill>
+                  <a:srgbClr val="78716C"/>
+                </a:solidFill>
+              </a:rPr>
+              <a:t>More data </a:t>
+            </a:r>
+            <a:r>
+              <a:rPr sz="2000" dirty="0">
+                <a:solidFill>
+                  <a:srgbClr val="78716C"/>
+                </a:solidFill>
+              </a:rPr>
+              <a:t>across more specialties with clinician validation.</a:t>
             </a:r>
           </a:p>
           <a:p>
             <a:pPr algn="l"/>
             <a:r>
-              <a:rPr sz="1500" b="1">
+              <a:rPr sz="2000" b="1" dirty="0">
                 <a:solidFill>
                   <a:srgbClr val="1C1717"/>
                 </a:solidFill>
@@ -7519,18 +7532,18 @@
               <a:t>•  Bi-encoder upgrade</a:t>
             </a:r>
             <a:r>
-              <a:rPr sz="1400">
-                <a:solidFill>
-                  <a:srgbClr val="78716C"/>
-                </a:solidFill>
-              </a:rPr>
-              <a:t>  — train the dual encoder on real clinician-rated query–FAQ pairs, not just keyword-derived positives.</a:t>
+              <a:rPr sz="2000" dirty="0">
+                <a:solidFill>
+                  <a:srgbClr val="78716C"/>
+                </a:solidFill>
+              </a:rPr>
+              <a:t>  train the dual encoder on real clinician-rated query–FAQ pairs, not just keyword-derived positives.</a:t>
             </a:r>
           </a:p>
           <a:p>
             <a:pPr algn="l"/>
             <a:r>
-              <a:rPr sz="1500" b="1">
+              <a:rPr sz="2000" b="1" dirty="0">
                 <a:solidFill>
                   <a:srgbClr val="1C1717"/>
                 </a:solidFill>
@@ -7538,18 +7551,18 @@
               <a:t>•  Active learning loop</a:t>
             </a:r>
             <a:r>
-              <a:rPr sz="1400">
-                <a:solidFill>
-                  <a:srgbClr val="78716C"/>
-                </a:solidFill>
-              </a:rPr>
-              <a:t>  — low-confidence turns get queued for clinician review; approved Q/A pairs feed back into the corpus.</a:t>
+              <a:rPr sz="2000" dirty="0">
+                <a:solidFill>
+                  <a:srgbClr val="78716C"/>
+                </a:solidFill>
+              </a:rPr>
+              <a:t>  low-confidence turns get queued for clinician review; approved Q/A pairs feed back into the corpus.</a:t>
             </a:r>
           </a:p>
           <a:p>
             <a:pPr algn="l"/>
             <a:r>
-              <a:rPr sz="1500" b="1">
+              <a:rPr sz="2000" b="1" dirty="0">
                 <a:solidFill>
                   <a:srgbClr val="1C1717"/>
                 </a:solidFill>
@@ -7557,18 +7570,18 @@
               <a:t>•  Real Urdu</a:t>
             </a:r>
             <a:r>
-              <a:rPr sz="1400">
-                <a:solidFill>
-                  <a:srgbClr val="78716C"/>
-                </a:solidFill>
-              </a:rPr>
-              <a:t>  — deeper transliteration trained on a parallel corpus; voice input in Urdu.</a:t>
+              <a:rPr sz="2000" dirty="0">
+                <a:solidFill>
+                  <a:srgbClr val="78716C"/>
+                </a:solidFill>
+              </a:rPr>
+              <a:t>  deeper transliteration trained on a parallel corpus; voice input in Urdu.</a:t>
             </a:r>
           </a:p>
           <a:p>
             <a:pPr algn="l"/>
             <a:r>
-              <a:rPr sz="1500" b="1">
+              <a:rPr sz="2000" b="1" dirty="0">
                 <a:solidFill>
                   <a:srgbClr val="1C1717"/>
                 </a:solidFill>
@@ -7576,50 +7589,12 @@
               <a:t>•  Clinical eval</a:t>
             </a:r>
             <a:r>
-              <a:rPr sz="1400">
-                <a:solidFill>
-                  <a:srgbClr val="78716C"/>
-                </a:solidFill>
-              </a:rPr>
-              <a:t>  — NDCG with clinician-rated relevance instead of a keyword heuristic.</a:t>
-            </a:r>
-          </a:p>
-          <a:p>
-            <a:pPr algn="l"/>
-            <a:r>
-              <a:rPr sz="1500" b="1">
-                <a:solidFill>
-                  <a:srgbClr val="1C1717"/>
-                </a:solidFill>
-              </a:rPr>
-              <a:t>•  GPU service</a:t>
-            </a:r>
-            <a:r>
-              <a:rPr sz="1400">
-                <a:solidFill>
-                  <a:srgbClr val="78716C"/>
-                </a:solidFill>
-              </a:rPr>
-              <a:t>  — dedicated container with CUDA wheel for heavier neural extensions.</a:t>
-            </a:r>
-          </a:p>
-          <a:p>
-            <a:pPr algn="l"/>
-            <a:r>
-              <a:rPr sz="1500" b="1">
-                <a:solidFill>
-                  <a:srgbClr val="1C1717"/>
-                </a:solidFill>
-              </a:rPr>
-              <a:t>•  Audit + governance</a:t>
-            </a:r>
-            <a:r>
-              <a:rPr sz="1400">
-                <a:solidFill>
-                  <a:srgbClr val="78716C"/>
-                </a:solidFill>
-              </a:rPr>
-              <a:t>  — version-controlled FAQ approval workflow, rollback, change-log.</a:t>
+              <a:rPr sz="2000" dirty="0">
+                <a:solidFill>
+                  <a:srgbClr val="78716C"/>
+                </a:solidFill>
+              </a:rPr>
+              <a:t>  NDCG with clinician-rated relevance instead of a keyword heuristic.</a:t>
             </a:r>
           </a:p>
         </p:txBody>

</xml_diff>